<commit_message>
added sql DB connection
</commit_message>
<xml_diff>
--- a/ML Project.pptx
+++ b/ML Project.pptx
@@ -5,15 +5,21 @@
     <p:sldMasterId id="2147483648" r:id="rId1"/>
   </p:sldMasterIdLst>
   <p:notesMasterIdLst>
-    <p:notesMasterId r:id="rId8"/>
+    <p:notesMasterId r:id="rId14"/>
   </p:notesMasterIdLst>
   <p:sldIdLst>
     <p:sldId id="257" r:id="rId2"/>
     <p:sldId id="258" r:id="rId3"/>
     <p:sldId id="266" r:id="rId4"/>
     <p:sldId id="259" r:id="rId5"/>
-    <p:sldId id="264" r:id="rId6"/>
-    <p:sldId id="265" r:id="rId7"/>
+    <p:sldId id="268" r:id="rId6"/>
+    <p:sldId id="269" r:id="rId7"/>
+    <p:sldId id="270" r:id="rId8"/>
+    <p:sldId id="267" r:id="rId9"/>
+    <p:sldId id="271" r:id="rId10"/>
+    <p:sldId id="264" r:id="rId11"/>
+    <p:sldId id="265" r:id="rId12"/>
+    <p:sldId id="272" r:id="rId13"/>
   </p:sldIdLst>
   <p:sldSz cx="12192000" cy="6858000"/>
   <p:notesSz cx="6858000" cy="9144000"/>
@@ -202,7 +208,7 @@
           <a:p>
             <a:fld id="{D31B73ED-5A7F-49D9-8DE0-65F5ABD04C5E}" type="datetimeFigureOut">
               <a:rPr lang="en-IN" smtClean="0"/>
-              <a:t>19-06-2026</a:t>
+              <a:t>21-06-2026</a:t>
             </a:fld>
             <a:endParaRPr lang="en-IN"/>
           </a:p>
@@ -579,6 +585,115 @@
 </p:notes>
 </file>
 
+<file path=ppt/notesSlides/notesSlide10.xml><?xml version="1.0" encoding="utf-8"?>
+<p:notes xmlns:a="http://schemas.openxmlformats.org/drawingml/2006/main" xmlns:r="http://schemas.openxmlformats.org/officeDocument/2006/relationships" xmlns:p="http://schemas.openxmlformats.org/presentationml/2006/main" showMasterSp="0" showMasterPhAnim="0">
+  <p:cSld>
+    <p:spTree>
+      <p:nvGrpSpPr>
+        <p:cNvPr id="1" name="Shape 386"/>
+        <p:cNvGrpSpPr/>
+        <p:nvPr/>
+      </p:nvGrpSpPr>
+      <p:grpSpPr>
+        <a:xfrm>
+          <a:off x="0" y="0"/>
+          <a:ext cx="0" cy="0"/>
+          <a:chOff x="0" y="0"/>
+          <a:chExt cx="0" cy="0"/>
+        </a:xfrm>
+      </p:grpSpPr>
+      <p:sp>
+        <p:nvSpPr>
+          <p:cNvPr id="387" name="Google Shape;387;gb7223bd2a0_0_331:notes"/>
+          <p:cNvSpPr>
+            <a:spLocks noGrp="1" noRot="1" noChangeAspect="1"/>
+          </p:cNvSpPr>
+          <p:nvPr>
+            <p:ph type="sldImg" idx="2"/>
+          </p:nvPr>
+        </p:nvSpPr>
+        <p:spPr>
+          <a:xfrm>
+            <a:off x="381000" y="685800"/>
+            <a:ext cx="6096000" cy="3429000"/>
+          </a:xfrm>
+          <a:custGeom>
+            <a:avLst/>
+            <a:gdLst/>
+            <a:ahLst/>
+            <a:cxnLst/>
+            <a:rect l="l" t="t" r="r" b="b"/>
+            <a:pathLst>
+              <a:path w="120000" h="120000" extrusionOk="0">
+                <a:moveTo>
+                  <a:pt x="0" y="0"/>
+                </a:moveTo>
+                <a:lnTo>
+                  <a:pt x="120000" y="0"/>
+                </a:lnTo>
+                <a:lnTo>
+                  <a:pt x="120000" y="120000"/>
+                </a:lnTo>
+                <a:lnTo>
+                  <a:pt x="0" y="120000"/>
+                </a:lnTo>
+                <a:close/>
+              </a:path>
+            </a:pathLst>
+          </a:custGeom>
+        </p:spPr>
+      </p:sp>
+      <p:sp>
+        <p:nvSpPr>
+          <p:cNvPr id="388" name="Google Shape;388;gb7223bd2a0_0_331:notes"/>
+          <p:cNvSpPr txBox="1">
+            <a:spLocks noGrp="1"/>
+          </p:cNvSpPr>
+          <p:nvPr>
+            <p:ph type="body" idx="1"/>
+          </p:nvPr>
+        </p:nvSpPr>
+        <p:spPr>
+          <a:xfrm>
+            <a:off x="685800" y="4343400"/>
+            <a:ext cx="5486400" cy="4114800"/>
+          </a:xfrm>
+          <a:prstGeom prst="rect">
+            <a:avLst/>
+          </a:prstGeom>
+        </p:spPr>
+        <p:txBody>
+          <a:bodyPr spcFirstLastPara="1" wrap="square" lIns="91425" tIns="91425" rIns="91425" bIns="91425" anchor="t" anchorCtr="0">
+            <a:noAutofit/>
+          </a:bodyPr>
+          <a:lstStyle/>
+          <a:p>
+            <a:pPr marL="0" lvl="0" indent="0" algn="l" rtl="0">
+              <a:spcBef>
+                <a:spcPts val="0"/>
+              </a:spcBef>
+              <a:spcAft>
+                <a:spcPts val="0"/>
+              </a:spcAft>
+              <a:buNone/>
+            </a:pPr>
+            <a:endParaRPr/>
+          </a:p>
+        </p:txBody>
+      </p:sp>
+    </p:spTree>
+    <p:extLst>
+      <p:ext uri="{BB962C8B-B14F-4D97-AF65-F5344CB8AC3E}">
+        <p14:creationId xmlns:p14="http://schemas.microsoft.com/office/powerpoint/2010/main" val="198410504"/>
+      </p:ext>
+    </p:extLst>
+  </p:cSld>
+  <p:clrMapOvr>
+    <a:masterClrMapping/>
+  </p:clrMapOvr>
+</p:notes>
+</file>
+
 <file path=ppt/notesSlides/notesSlide2.xml><?xml version="1.0" encoding="utf-8"?>
 <p:notes xmlns:a="http://schemas.openxmlformats.org/drawingml/2006/main" xmlns:r="http://schemas.openxmlformats.org/officeDocument/2006/relationships" xmlns:p="http://schemas.openxmlformats.org/presentationml/2006/main" showMasterSp="0" showMasterPhAnim="0">
   <p:cSld>
@@ -911,7 +1026,13 @@
   <p:cSld>
     <p:spTree>
       <p:nvGrpSpPr>
-        <p:cNvPr id="1" name="Shape 386"/>
+        <p:cNvPr id="1" name="Shape 346">
+          <a:extLst>
+            <a:ext uri="{FF2B5EF4-FFF2-40B4-BE49-F238E27FC236}">
+              <a16:creationId xmlns:a16="http://schemas.microsoft.com/office/drawing/2014/main" id="{F2E9EA19-0911-2470-D9AC-EB9C3C0F04EC}"/>
+            </a:ext>
+          </a:extLst>
+        </p:cNvPr>
         <p:cNvGrpSpPr/>
         <p:nvPr/>
       </p:nvGrpSpPr>
@@ -925,7 +1046,13 @@
       </p:grpSpPr>
       <p:sp>
         <p:nvSpPr>
-          <p:cNvPr id="387" name="Google Shape;387;gb7223bd2a0_0_331:notes"/>
+          <p:cNvPr id="347" name="Google Shape;347;gb7223bd2a0_0_349:notes">
+            <a:extLst>
+              <a:ext uri="{FF2B5EF4-FFF2-40B4-BE49-F238E27FC236}">
+                <a16:creationId xmlns:a16="http://schemas.microsoft.com/office/drawing/2014/main" id="{9D025597-9C59-C03C-6AFD-17B0786E9DBC}"/>
+              </a:ext>
+            </a:extLst>
+          </p:cNvPr>
           <p:cNvSpPr>
             <a:spLocks noGrp="1" noRot="1" noChangeAspect="1"/>
           </p:cNvSpPr>
@@ -966,7 +1093,13 @@
       </p:sp>
       <p:sp>
         <p:nvSpPr>
-          <p:cNvPr id="388" name="Google Shape;388;gb7223bd2a0_0_331:notes"/>
+          <p:cNvPr id="348" name="Google Shape;348;gb7223bd2a0_0_349:notes">
+            <a:extLst>
+              <a:ext uri="{FF2B5EF4-FFF2-40B4-BE49-F238E27FC236}">
+                <a16:creationId xmlns:a16="http://schemas.microsoft.com/office/drawing/2014/main" id="{5F383D70-DFDD-2B57-AE82-EF759BE63796}"/>
+              </a:ext>
+            </a:extLst>
+          </p:cNvPr>
           <p:cNvSpPr txBox="1">
             <a:spLocks noGrp="1"/>
           </p:cNvSpPr>
@@ -1005,7 +1138,7 @@
     </p:spTree>
     <p:extLst>
       <p:ext uri="{BB962C8B-B14F-4D97-AF65-F5344CB8AC3E}">
-        <p14:creationId xmlns:p14="http://schemas.microsoft.com/office/powerpoint/2010/main" val="411403113"/>
+        <p14:creationId xmlns:p14="http://schemas.microsoft.com/office/powerpoint/2010/main" val="1024305991"/>
       </p:ext>
     </p:extLst>
   </p:cSld>
@@ -1020,7 +1153,13 @@
   <p:cSld>
     <p:spTree>
       <p:nvGrpSpPr>
-        <p:cNvPr id="1" name="Shape 386"/>
+        <p:cNvPr id="1" name="Shape 346">
+          <a:extLst>
+            <a:ext uri="{FF2B5EF4-FFF2-40B4-BE49-F238E27FC236}">
+              <a16:creationId xmlns:a16="http://schemas.microsoft.com/office/drawing/2014/main" id="{4018AAC2-1D37-ECA5-B559-96EEF0B3CC44}"/>
+            </a:ext>
+          </a:extLst>
+        </p:cNvPr>
         <p:cNvGrpSpPr/>
         <p:nvPr/>
       </p:nvGrpSpPr>
@@ -1034,7 +1173,13 @@
       </p:grpSpPr>
       <p:sp>
         <p:nvSpPr>
-          <p:cNvPr id="387" name="Google Shape;387;gb7223bd2a0_0_331:notes"/>
+          <p:cNvPr id="347" name="Google Shape;347;gb7223bd2a0_0_349:notes">
+            <a:extLst>
+              <a:ext uri="{FF2B5EF4-FFF2-40B4-BE49-F238E27FC236}">
+                <a16:creationId xmlns:a16="http://schemas.microsoft.com/office/drawing/2014/main" id="{7189F3E7-9251-A83F-6563-6805547329A8}"/>
+              </a:ext>
+            </a:extLst>
+          </p:cNvPr>
           <p:cNvSpPr>
             <a:spLocks noGrp="1" noRot="1" noChangeAspect="1"/>
           </p:cNvSpPr>
@@ -1075,7 +1220,13 @@
       </p:sp>
       <p:sp>
         <p:nvSpPr>
-          <p:cNvPr id="388" name="Google Shape;388;gb7223bd2a0_0_331:notes"/>
+          <p:cNvPr id="348" name="Google Shape;348;gb7223bd2a0_0_349:notes">
+            <a:extLst>
+              <a:ext uri="{FF2B5EF4-FFF2-40B4-BE49-F238E27FC236}">
+                <a16:creationId xmlns:a16="http://schemas.microsoft.com/office/drawing/2014/main" id="{8180E596-4492-D7AB-2A8B-F462CB78148A}"/>
+              </a:ext>
+            </a:extLst>
+          </p:cNvPr>
           <p:cNvSpPr txBox="1">
             <a:spLocks noGrp="1"/>
           </p:cNvSpPr>
@@ -1107,14 +1258,377 @@
               </a:spcAft>
               <a:buNone/>
             </a:pPr>
-            <a:endParaRPr/>
+            <a:endParaRPr dirty="0"/>
           </a:p>
         </p:txBody>
       </p:sp>
     </p:spTree>
     <p:extLst>
       <p:ext uri="{BB962C8B-B14F-4D97-AF65-F5344CB8AC3E}">
-        <p14:creationId xmlns:p14="http://schemas.microsoft.com/office/powerpoint/2010/main" val="198410504"/>
+        <p14:creationId xmlns:p14="http://schemas.microsoft.com/office/powerpoint/2010/main" val="3408561453"/>
+      </p:ext>
+    </p:extLst>
+  </p:cSld>
+  <p:clrMapOvr>
+    <a:masterClrMapping/>
+  </p:clrMapOvr>
+</p:notes>
+</file>
+
+<file path=ppt/notesSlides/notesSlide7.xml><?xml version="1.0" encoding="utf-8"?>
+<p:notes xmlns:a="http://schemas.openxmlformats.org/drawingml/2006/main" xmlns:r="http://schemas.openxmlformats.org/officeDocument/2006/relationships" xmlns:p="http://schemas.openxmlformats.org/presentationml/2006/main" showMasterSp="0" showMasterPhAnim="0">
+  <p:cSld>
+    <p:spTree>
+      <p:nvGrpSpPr>
+        <p:cNvPr id="1" name="Shape 346">
+          <a:extLst>
+            <a:ext uri="{FF2B5EF4-FFF2-40B4-BE49-F238E27FC236}">
+              <a16:creationId xmlns:a16="http://schemas.microsoft.com/office/drawing/2014/main" id="{548B818D-22D0-B719-B144-819CDC6247B6}"/>
+            </a:ext>
+          </a:extLst>
+        </p:cNvPr>
+        <p:cNvGrpSpPr/>
+        <p:nvPr/>
+      </p:nvGrpSpPr>
+      <p:grpSpPr>
+        <a:xfrm>
+          <a:off x="0" y="0"/>
+          <a:ext cx="0" cy="0"/>
+          <a:chOff x="0" y="0"/>
+          <a:chExt cx="0" cy="0"/>
+        </a:xfrm>
+      </p:grpSpPr>
+      <p:sp>
+        <p:nvSpPr>
+          <p:cNvPr id="347" name="Google Shape;347;gb7223bd2a0_0_349:notes">
+            <a:extLst>
+              <a:ext uri="{FF2B5EF4-FFF2-40B4-BE49-F238E27FC236}">
+                <a16:creationId xmlns:a16="http://schemas.microsoft.com/office/drawing/2014/main" id="{78C4D132-C854-E794-05AF-D43C9477842C}"/>
+              </a:ext>
+            </a:extLst>
+          </p:cNvPr>
+          <p:cNvSpPr>
+            <a:spLocks noGrp="1" noRot="1" noChangeAspect="1"/>
+          </p:cNvSpPr>
+          <p:nvPr>
+            <p:ph type="sldImg" idx="2"/>
+          </p:nvPr>
+        </p:nvSpPr>
+        <p:spPr>
+          <a:xfrm>
+            <a:off x="381000" y="685800"/>
+            <a:ext cx="6096000" cy="3429000"/>
+          </a:xfrm>
+          <a:custGeom>
+            <a:avLst/>
+            <a:gdLst/>
+            <a:ahLst/>
+            <a:cxnLst/>
+            <a:rect l="l" t="t" r="r" b="b"/>
+            <a:pathLst>
+              <a:path w="120000" h="120000" extrusionOk="0">
+                <a:moveTo>
+                  <a:pt x="0" y="0"/>
+                </a:moveTo>
+                <a:lnTo>
+                  <a:pt x="120000" y="0"/>
+                </a:lnTo>
+                <a:lnTo>
+                  <a:pt x="120000" y="120000"/>
+                </a:lnTo>
+                <a:lnTo>
+                  <a:pt x="0" y="120000"/>
+                </a:lnTo>
+                <a:close/>
+              </a:path>
+            </a:pathLst>
+          </a:custGeom>
+        </p:spPr>
+      </p:sp>
+      <p:sp>
+        <p:nvSpPr>
+          <p:cNvPr id="348" name="Google Shape;348;gb7223bd2a0_0_349:notes">
+            <a:extLst>
+              <a:ext uri="{FF2B5EF4-FFF2-40B4-BE49-F238E27FC236}">
+                <a16:creationId xmlns:a16="http://schemas.microsoft.com/office/drawing/2014/main" id="{B80C78D0-086B-A6DF-CE3A-45C497F4E476}"/>
+              </a:ext>
+            </a:extLst>
+          </p:cNvPr>
+          <p:cNvSpPr txBox="1">
+            <a:spLocks noGrp="1"/>
+          </p:cNvSpPr>
+          <p:nvPr>
+            <p:ph type="body" idx="1"/>
+          </p:nvPr>
+        </p:nvSpPr>
+        <p:spPr>
+          <a:xfrm>
+            <a:off x="685800" y="4343400"/>
+            <a:ext cx="5486400" cy="4114800"/>
+          </a:xfrm>
+          <a:prstGeom prst="rect">
+            <a:avLst/>
+          </a:prstGeom>
+        </p:spPr>
+        <p:txBody>
+          <a:bodyPr spcFirstLastPara="1" wrap="square" lIns="91425" tIns="91425" rIns="91425" bIns="91425" anchor="t" anchorCtr="0">
+            <a:noAutofit/>
+          </a:bodyPr>
+          <a:lstStyle/>
+          <a:p>
+            <a:pPr marL="0" lvl="0" indent="0" algn="l" rtl="0">
+              <a:spcBef>
+                <a:spcPts val="0"/>
+              </a:spcBef>
+              <a:spcAft>
+                <a:spcPts val="0"/>
+              </a:spcAft>
+              <a:buNone/>
+            </a:pPr>
+            <a:endParaRPr dirty="0"/>
+          </a:p>
+        </p:txBody>
+      </p:sp>
+    </p:spTree>
+    <p:extLst>
+      <p:ext uri="{BB962C8B-B14F-4D97-AF65-F5344CB8AC3E}">
+        <p14:creationId xmlns:p14="http://schemas.microsoft.com/office/powerpoint/2010/main" val="1090212315"/>
+      </p:ext>
+    </p:extLst>
+  </p:cSld>
+  <p:clrMapOvr>
+    <a:masterClrMapping/>
+  </p:clrMapOvr>
+</p:notes>
+</file>
+
+<file path=ppt/notesSlides/notesSlide8.xml><?xml version="1.0" encoding="utf-8"?>
+<p:notes xmlns:a="http://schemas.openxmlformats.org/drawingml/2006/main" xmlns:r="http://schemas.openxmlformats.org/officeDocument/2006/relationships" xmlns:p="http://schemas.openxmlformats.org/presentationml/2006/main" showMasterSp="0" showMasterPhAnim="0">
+  <p:cSld>
+    <p:spTree>
+      <p:nvGrpSpPr>
+        <p:cNvPr id="1" name="Shape 346">
+          <a:extLst>
+            <a:ext uri="{FF2B5EF4-FFF2-40B4-BE49-F238E27FC236}">
+              <a16:creationId xmlns:a16="http://schemas.microsoft.com/office/drawing/2014/main" id="{4FBB3570-003D-D10A-8EFC-D68C2CF5F0B0}"/>
+            </a:ext>
+          </a:extLst>
+        </p:cNvPr>
+        <p:cNvGrpSpPr/>
+        <p:nvPr/>
+      </p:nvGrpSpPr>
+      <p:grpSpPr>
+        <a:xfrm>
+          <a:off x="0" y="0"/>
+          <a:ext cx="0" cy="0"/>
+          <a:chOff x="0" y="0"/>
+          <a:chExt cx="0" cy="0"/>
+        </a:xfrm>
+      </p:grpSpPr>
+      <p:sp>
+        <p:nvSpPr>
+          <p:cNvPr id="347" name="Google Shape;347;gb7223bd2a0_0_349:notes">
+            <a:extLst>
+              <a:ext uri="{FF2B5EF4-FFF2-40B4-BE49-F238E27FC236}">
+                <a16:creationId xmlns:a16="http://schemas.microsoft.com/office/drawing/2014/main" id="{3461CD93-0FE6-F9C7-2B38-7266F1090B04}"/>
+              </a:ext>
+            </a:extLst>
+          </p:cNvPr>
+          <p:cNvSpPr>
+            <a:spLocks noGrp="1" noRot="1" noChangeAspect="1"/>
+          </p:cNvSpPr>
+          <p:nvPr>
+            <p:ph type="sldImg" idx="2"/>
+          </p:nvPr>
+        </p:nvSpPr>
+        <p:spPr>
+          <a:xfrm>
+            <a:off x="381000" y="685800"/>
+            <a:ext cx="6096000" cy="3429000"/>
+          </a:xfrm>
+          <a:custGeom>
+            <a:avLst/>
+            <a:gdLst/>
+            <a:ahLst/>
+            <a:cxnLst/>
+            <a:rect l="l" t="t" r="r" b="b"/>
+            <a:pathLst>
+              <a:path w="120000" h="120000" extrusionOk="0">
+                <a:moveTo>
+                  <a:pt x="0" y="0"/>
+                </a:moveTo>
+                <a:lnTo>
+                  <a:pt x="120000" y="0"/>
+                </a:lnTo>
+                <a:lnTo>
+                  <a:pt x="120000" y="120000"/>
+                </a:lnTo>
+                <a:lnTo>
+                  <a:pt x="0" y="120000"/>
+                </a:lnTo>
+                <a:close/>
+              </a:path>
+            </a:pathLst>
+          </a:custGeom>
+        </p:spPr>
+      </p:sp>
+      <p:sp>
+        <p:nvSpPr>
+          <p:cNvPr id="348" name="Google Shape;348;gb7223bd2a0_0_349:notes">
+            <a:extLst>
+              <a:ext uri="{FF2B5EF4-FFF2-40B4-BE49-F238E27FC236}">
+                <a16:creationId xmlns:a16="http://schemas.microsoft.com/office/drawing/2014/main" id="{0D9CCE7D-D1DD-CAB7-585F-9453BA56DD77}"/>
+              </a:ext>
+            </a:extLst>
+          </p:cNvPr>
+          <p:cNvSpPr txBox="1">
+            <a:spLocks noGrp="1"/>
+          </p:cNvSpPr>
+          <p:nvPr>
+            <p:ph type="body" idx="1"/>
+          </p:nvPr>
+        </p:nvSpPr>
+        <p:spPr>
+          <a:xfrm>
+            <a:off x="685800" y="4343400"/>
+            <a:ext cx="5486400" cy="4114800"/>
+          </a:xfrm>
+          <a:prstGeom prst="rect">
+            <a:avLst/>
+          </a:prstGeom>
+        </p:spPr>
+        <p:txBody>
+          <a:bodyPr spcFirstLastPara="1" wrap="square" lIns="91425" tIns="91425" rIns="91425" bIns="91425" anchor="t" anchorCtr="0">
+            <a:noAutofit/>
+          </a:bodyPr>
+          <a:lstStyle/>
+          <a:p>
+            <a:pPr marL="0" lvl="0" indent="0" algn="l" rtl="0">
+              <a:spcBef>
+                <a:spcPts val="0"/>
+              </a:spcBef>
+              <a:spcAft>
+                <a:spcPts val="0"/>
+              </a:spcAft>
+              <a:buNone/>
+            </a:pPr>
+            <a:endParaRPr dirty="0"/>
+          </a:p>
+        </p:txBody>
+      </p:sp>
+    </p:spTree>
+    <p:extLst>
+      <p:ext uri="{BB962C8B-B14F-4D97-AF65-F5344CB8AC3E}">
+        <p14:creationId xmlns:p14="http://schemas.microsoft.com/office/powerpoint/2010/main" val="3024212907"/>
+      </p:ext>
+    </p:extLst>
+  </p:cSld>
+  <p:clrMapOvr>
+    <a:masterClrMapping/>
+  </p:clrMapOvr>
+</p:notes>
+</file>
+
+<file path=ppt/notesSlides/notesSlide9.xml><?xml version="1.0" encoding="utf-8"?>
+<p:notes xmlns:a="http://schemas.openxmlformats.org/drawingml/2006/main" xmlns:r="http://schemas.openxmlformats.org/officeDocument/2006/relationships" xmlns:p="http://schemas.openxmlformats.org/presentationml/2006/main" showMasterSp="0" showMasterPhAnim="0">
+  <p:cSld>
+    <p:spTree>
+      <p:nvGrpSpPr>
+        <p:cNvPr id="1" name="Shape 386"/>
+        <p:cNvGrpSpPr/>
+        <p:nvPr/>
+      </p:nvGrpSpPr>
+      <p:grpSpPr>
+        <a:xfrm>
+          <a:off x="0" y="0"/>
+          <a:ext cx="0" cy="0"/>
+          <a:chOff x="0" y="0"/>
+          <a:chExt cx="0" cy="0"/>
+        </a:xfrm>
+      </p:grpSpPr>
+      <p:sp>
+        <p:nvSpPr>
+          <p:cNvPr id="387" name="Google Shape;387;gb7223bd2a0_0_331:notes"/>
+          <p:cNvSpPr>
+            <a:spLocks noGrp="1" noRot="1" noChangeAspect="1"/>
+          </p:cNvSpPr>
+          <p:nvPr>
+            <p:ph type="sldImg" idx="2"/>
+          </p:nvPr>
+        </p:nvSpPr>
+        <p:spPr>
+          <a:xfrm>
+            <a:off x="381000" y="685800"/>
+            <a:ext cx="6096000" cy="3429000"/>
+          </a:xfrm>
+          <a:custGeom>
+            <a:avLst/>
+            <a:gdLst/>
+            <a:ahLst/>
+            <a:cxnLst/>
+            <a:rect l="l" t="t" r="r" b="b"/>
+            <a:pathLst>
+              <a:path w="120000" h="120000" extrusionOk="0">
+                <a:moveTo>
+                  <a:pt x="0" y="0"/>
+                </a:moveTo>
+                <a:lnTo>
+                  <a:pt x="120000" y="0"/>
+                </a:lnTo>
+                <a:lnTo>
+                  <a:pt x="120000" y="120000"/>
+                </a:lnTo>
+                <a:lnTo>
+                  <a:pt x="0" y="120000"/>
+                </a:lnTo>
+                <a:close/>
+              </a:path>
+            </a:pathLst>
+          </a:custGeom>
+        </p:spPr>
+      </p:sp>
+      <p:sp>
+        <p:nvSpPr>
+          <p:cNvPr id="388" name="Google Shape;388;gb7223bd2a0_0_331:notes"/>
+          <p:cNvSpPr txBox="1">
+            <a:spLocks noGrp="1"/>
+          </p:cNvSpPr>
+          <p:nvPr>
+            <p:ph type="body" idx="1"/>
+          </p:nvPr>
+        </p:nvSpPr>
+        <p:spPr>
+          <a:xfrm>
+            <a:off x="685800" y="4343400"/>
+            <a:ext cx="5486400" cy="4114800"/>
+          </a:xfrm>
+          <a:prstGeom prst="rect">
+            <a:avLst/>
+          </a:prstGeom>
+        </p:spPr>
+        <p:txBody>
+          <a:bodyPr spcFirstLastPara="1" wrap="square" lIns="91425" tIns="91425" rIns="91425" bIns="91425" anchor="t" anchorCtr="0">
+            <a:noAutofit/>
+          </a:bodyPr>
+          <a:lstStyle/>
+          <a:p>
+            <a:pPr marL="0" lvl="0" indent="0" algn="l" rtl="0">
+              <a:spcBef>
+                <a:spcPts val="0"/>
+              </a:spcBef>
+              <a:spcAft>
+                <a:spcPts val="0"/>
+              </a:spcAft>
+              <a:buNone/>
+            </a:pPr>
+            <a:endParaRPr dirty="0"/>
+          </a:p>
+        </p:txBody>
+      </p:sp>
+    </p:spTree>
+    <p:extLst>
+      <p:ext uri="{BB962C8B-B14F-4D97-AF65-F5344CB8AC3E}">
+        <p14:creationId xmlns:p14="http://schemas.microsoft.com/office/powerpoint/2010/main" val="411403113"/>
       </p:ext>
     </p:extLst>
   </p:cSld>
@@ -1255,7 +1769,7 @@
           <a:p>
             <a:fld id="{538F6550-DC47-412E-A6BD-C043C18783D6}" type="datetimeFigureOut">
               <a:rPr lang="en-IN" smtClean="0"/>
-              <a:t>19-06-2026</a:t>
+              <a:t>21-06-2026</a:t>
             </a:fld>
             <a:endParaRPr lang="en-IN"/>
           </a:p>
@@ -1425,7 +1939,7 @@
           <a:p>
             <a:fld id="{538F6550-DC47-412E-A6BD-C043C18783D6}" type="datetimeFigureOut">
               <a:rPr lang="en-IN" smtClean="0"/>
-              <a:t>19-06-2026</a:t>
+              <a:t>21-06-2026</a:t>
             </a:fld>
             <a:endParaRPr lang="en-IN"/>
           </a:p>
@@ -1605,7 +2119,7 @@
           <a:p>
             <a:fld id="{538F6550-DC47-412E-A6BD-C043C18783D6}" type="datetimeFigureOut">
               <a:rPr lang="en-IN" smtClean="0"/>
-              <a:t>19-06-2026</a:t>
+              <a:t>21-06-2026</a:t>
             </a:fld>
             <a:endParaRPr lang="en-IN"/>
           </a:p>
@@ -1775,7 +2289,7 @@
           <a:p>
             <a:fld id="{538F6550-DC47-412E-A6BD-C043C18783D6}" type="datetimeFigureOut">
               <a:rPr lang="en-IN" smtClean="0"/>
-              <a:t>19-06-2026</a:t>
+              <a:t>21-06-2026</a:t>
             </a:fld>
             <a:endParaRPr lang="en-IN"/>
           </a:p>
@@ -2021,7 +2535,7 @@
           <a:p>
             <a:fld id="{538F6550-DC47-412E-A6BD-C043C18783D6}" type="datetimeFigureOut">
               <a:rPr lang="en-IN" smtClean="0"/>
-              <a:t>19-06-2026</a:t>
+              <a:t>21-06-2026</a:t>
             </a:fld>
             <a:endParaRPr lang="en-IN"/>
           </a:p>
@@ -2253,7 +2767,7 @@
           <a:p>
             <a:fld id="{538F6550-DC47-412E-A6BD-C043C18783D6}" type="datetimeFigureOut">
               <a:rPr lang="en-IN" smtClean="0"/>
-              <a:t>19-06-2026</a:t>
+              <a:t>21-06-2026</a:t>
             </a:fld>
             <a:endParaRPr lang="en-IN"/>
           </a:p>
@@ -2620,7 +3134,7 @@
           <a:p>
             <a:fld id="{538F6550-DC47-412E-A6BD-C043C18783D6}" type="datetimeFigureOut">
               <a:rPr lang="en-IN" smtClean="0"/>
-              <a:t>19-06-2026</a:t>
+              <a:t>21-06-2026</a:t>
             </a:fld>
             <a:endParaRPr lang="en-IN"/>
           </a:p>
@@ -2738,7 +3252,7 @@
           <a:p>
             <a:fld id="{538F6550-DC47-412E-A6BD-C043C18783D6}" type="datetimeFigureOut">
               <a:rPr lang="en-IN" smtClean="0"/>
-              <a:t>19-06-2026</a:t>
+              <a:t>21-06-2026</a:t>
             </a:fld>
             <a:endParaRPr lang="en-IN"/>
           </a:p>
@@ -2833,7 +3347,7 @@
           <a:p>
             <a:fld id="{538F6550-DC47-412E-A6BD-C043C18783D6}" type="datetimeFigureOut">
               <a:rPr lang="en-IN" smtClean="0"/>
-              <a:t>19-06-2026</a:t>
+              <a:t>21-06-2026</a:t>
             </a:fld>
             <a:endParaRPr lang="en-IN"/>
           </a:p>
@@ -3110,7 +3624,7 @@
           <a:p>
             <a:fld id="{538F6550-DC47-412E-A6BD-C043C18783D6}" type="datetimeFigureOut">
               <a:rPr lang="en-IN" smtClean="0"/>
-              <a:t>19-06-2026</a:t>
+              <a:t>21-06-2026</a:t>
             </a:fld>
             <a:endParaRPr lang="en-IN"/>
           </a:p>
@@ -3363,7 +3877,7 @@
           <a:p>
             <a:fld id="{538F6550-DC47-412E-A6BD-C043C18783D6}" type="datetimeFigureOut">
               <a:rPr lang="en-IN" smtClean="0"/>
-              <a:t>19-06-2026</a:t>
+              <a:t>21-06-2026</a:t>
             </a:fld>
             <a:endParaRPr lang="en-IN"/>
           </a:p>
@@ -3576,7 +4090,7 @@
           <a:p>
             <a:fld id="{538F6550-DC47-412E-A6BD-C043C18783D6}" type="datetimeFigureOut">
               <a:rPr lang="en-IN" smtClean="0"/>
-              <a:t>19-06-2026</a:t>
+              <a:t>21-06-2026</a:t>
             </a:fld>
             <a:endParaRPr lang="en-IN"/>
           </a:p>
@@ -3981,6 +4495,131 @@
           <a:chExt cx="0" cy="0"/>
         </a:xfrm>
       </p:grpSpPr>
+      <p:pic>
+        <p:nvPicPr>
+          <p:cNvPr id="6" name="Picture 5">
+            <a:extLst>
+              <a:ext uri="{FF2B5EF4-FFF2-40B4-BE49-F238E27FC236}">
+                <a16:creationId xmlns:a16="http://schemas.microsoft.com/office/drawing/2014/main" id="{43CDD6BF-C831-F711-282A-50C27359E9E7}"/>
+              </a:ext>
+            </a:extLst>
+          </p:cNvPr>
+          <p:cNvPicPr>
+            <a:picLocks noChangeAspect="1"/>
+          </p:cNvPicPr>
+          <p:nvPr/>
+        </p:nvPicPr>
+        <p:blipFill>
+          <a:blip r:embed="rId3">
+            <a:alphaModFix amt="20000"/>
+            <a:extLst>
+              <a:ext uri="{BEBA8EAE-BF5A-486C-A8C5-ECC9F3942E4B}">
+                <a14:imgProps xmlns:a14="http://schemas.microsoft.com/office/drawing/2010/main">
+                  <a14:imgLayer r:embed="rId4">
+                    <a14:imgEffect>
+                      <a14:backgroundRemoval t="9967" b="89869" l="9967" r="91993">
+                        <a14:foregroundMark x1="14216" y1="24673" x2="14216" y2="24673"/>
+                        <a14:foregroundMark x1="55229" y1="16503" x2="55229" y2="16503"/>
+                        <a14:foregroundMark x1="80556" y1="16503" x2="80556" y2="16503"/>
+                        <a14:foregroundMark x1="74183" y1="48693" x2="74183" y2="48693"/>
+                        <a14:foregroundMark x1="49346" y1="51471" x2="49346" y2="51471"/>
+                        <a14:foregroundMark x1="20261" y1="47386" x2="20261" y2="47386"/>
+                        <a14:foregroundMark x1="19281" y1="78431" x2="19281" y2="78431"/>
+                        <a14:foregroundMark x1="53595" y1="75654" x2="53595" y2="75654"/>
+                        <a14:foregroundMark x1="12092" y1="70915" x2="12092" y2="70915"/>
+                        <a14:foregroundMark x1="91993" y1="77778" x2="91993" y2="77778"/>
+                        <a14:foregroundMark x1="25980" y1="23366" x2="25980" y2="23366"/>
+                        <a14:foregroundMark x1="53922" y1="24673" x2="53922" y2="24673"/>
+                        <a14:foregroundMark x1="73039" y1="52614" x2="73039" y2="52614"/>
+                        <a14:foregroundMark x1="54575" y1="82680" x2="54575" y2="82680"/>
+                        <a14:foregroundMark x1="20915" y1="52941" x2="20915" y2="52941"/>
+                      </a14:backgroundRemoval>
+                    </a14:imgEffect>
+                  </a14:imgLayer>
+                </a14:imgProps>
+              </a:ext>
+              <a:ext uri="{28A0092B-C50C-407E-A947-70E740481C1C}">
+                <a14:useLocalDpi xmlns:a14="http://schemas.microsoft.com/office/drawing/2010/main" val="0"/>
+              </a:ext>
+            </a:extLst>
+          </a:blip>
+          <a:stretch>
+            <a:fillRect/>
+          </a:stretch>
+        </p:blipFill>
+        <p:spPr>
+          <a:xfrm>
+            <a:off x="-298579" y="-470460"/>
+            <a:ext cx="7529804" cy="7529804"/>
+          </a:xfrm>
+          <a:prstGeom prst="rect">
+            <a:avLst/>
+          </a:prstGeom>
+        </p:spPr>
+      </p:pic>
+      <p:pic>
+        <p:nvPicPr>
+          <p:cNvPr id="7" name="Picture 6">
+            <a:extLst>
+              <a:ext uri="{FF2B5EF4-FFF2-40B4-BE49-F238E27FC236}">
+                <a16:creationId xmlns:a16="http://schemas.microsoft.com/office/drawing/2014/main" id="{43B8B262-1E9F-B0C4-495F-10D807CF9FB8}"/>
+              </a:ext>
+            </a:extLst>
+          </p:cNvPr>
+          <p:cNvPicPr>
+            <a:picLocks noChangeAspect="1"/>
+          </p:cNvPicPr>
+          <p:nvPr/>
+        </p:nvPicPr>
+        <p:blipFill>
+          <a:blip r:embed="rId3">
+            <a:alphaModFix amt="20000"/>
+            <a:extLst>
+              <a:ext uri="{BEBA8EAE-BF5A-486C-A8C5-ECC9F3942E4B}">
+                <a14:imgProps xmlns:a14="http://schemas.microsoft.com/office/drawing/2010/main">
+                  <a14:imgLayer r:embed="rId4">
+                    <a14:imgEffect>
+                      <a14:backgroundRemoval t="9967" b="89869" l="9967" r="91993">
+                        <a14:foregroundMark x1="14216" y1="24673" x2="14216" y2="24673"/>
+                        <a14:foregroundMark x1="55229" y1="16503" x2="55229" y2="16503"/>
+                        <a14:foregroundMark x1="80556" y1="16503" x2="80556" y2="16503"/>
+                        <a14:foregroundMark x1="74183" y1="48693" x2="74183" y2="48693"/>
+                        <a14:foregroundMark x1="49346" y1="51471" x2="49346" y2="51471"/>
+                        <a14:foregroundMark x1="20261" y1="47386" x2="20261" y2="47386"/>
+                        <a14:foregroundMark x1="19281" y1="78431" x2="19281" y2="78431"/>
+                        <a14:foregroundMark x1="53595" y1="75654" x2="53595" y2="75654"/>
+                        <a14:foregroundMark x1="12092" y1="70915" x2="12092" y2="70915"/>
+                        <a14:foregroundMark x1="91993" y1="77778" x2="91993" y2="77778"/>
+                        <a14:foregroundMark x1="25980" y1="23366" x2="25980" y2="23366"/>
+                        <a14:foregroundMark x1="53922" y1="24673" x2="53922" y2="24673"/>
+                        <a14:foregroundMark x1="73039" y1="52614" x2="73039" y2="52614"/>
+                        <a14:foregroundMark x1="54575" y1="82680" x2="54575" y2="82680"/>
+                        <a14:foregroundMark x1="20915" y1="52941" x2="20915" y2="52941"/>
+                      </a14:backgroundRemoval>
+                    </a14:imgEffect>
+                  </a14:imgLayer>
+                </a14:imgProps>
+              </a:ext>
+              <a:ext uri="{28A0092B-C50C-407E-A947-70E740481C1C}">
+                <a14:useLocalDpi xmlns:a14="http://schemas.microsoft.com/office/drawing/2010/main" val="0"/>
+              </a:ext>
+            </a:extLst>
+          </a:blip>
+          <a:srcRect r="23255"/>
+          <a:stretch>
+            <a:fillRect/>
+          </a:stretch>
+        </p:blipFill>
+        <p:spPr>
+          <a:xfrm>
+            <a:off x="6413241" y="-768204"/>
+            <a:ext cx="5778759" cy="7529804"/>
+          </a:xfrm>
+          <a:prstGeom prst="rect">
+            <a:avLst/>
+          </a:prstGeom>
+        </p:spPr>
+      </p:pic>
       <p:sp>
         <p:nvSpPr>
           <p:cNvPr id="330" name="Google Shape;330;p13"/>
@@ -3995,7 +4634,9 @@
           <a:prstGeom prst="rect">
             <a:avLst/>
           </a:prstGeom>
-          <a:noFill/>
+          <a:solidFill>
+            <a:schemeClr val="bg1"/>
+          </a:solidFill>
           <a:ln>
             <a:noFill/>
           </a:ln>
@@ -4191,7 +4832,9 @@
           <a:prstGeom prst="rect">
             <a:avLst/>
           </a:prstGeom>
-          <a:noFill/>
+          <a:solidFill>
+            <a:schemeClr val="bg1"/>
+          </a:solidFill>
         </p:spPr>
         <p:txBody>
           <a:bodyPr wrap="square" rtlCol="0">
@@ -4245,7 +4888,7 @@
           <p:nvPr/>
         </p:nvPicPr>
         <p:blipFill>
-          <a:blip r:embed="rId3" cstate="print">
+          <a:blip r:embed="rId5" cstate="print">
             <a:extLst>
               <a:ext uri="{28A0092B-C50C-407E-A947-70E740481C1C}">
                 <a14:useLocalDpi xmlns:a14="http://schemas.microsoft.com/office/drawing/2010/main" val="0"/>
@@ -4280,13 +4923,15 @@
         </p:nvSpPr>
         <p:spPr>
           <a:xfrm>
-            <a:off x="1094792" y="3294442"/>
-            <a:ext cx="10002416" cy="677108"/>
+            <a:off x="3138676" y="3325217"/>
+            <a:ext cx="6040016" cy="677108"/>
           </a:xfrm>
           <a:prstGeom prst="rect">
             <a:avLst/>
           </a:prstGeom>
-          <a:noFill/>
+          <a:solidFill>
+            <a:schemeClr val="bg1"/>
+          </a:solidFill>
         </p:spPr>
         <p:txBody>
           <a:bodyPr wrap="square" rtlCol="0">
@@ -4343,6 +4988,1109 @@
     <p:extLst>
       <p:ext uri="{BB962C8B-B14F-4D97-AF65-F5344CB8AC3E}">
         <p14:creationId xmlns:p14="http://schemas.microsoft.com/office/powerpoint/2010/main" val="1478729324"/>
+      </p:ext>
+    </p:extLst>
+  </p:cSld>
+  <p:clrMapOvr>
+    <a:masterClrMapping/>
+  </p:clrMapOvr>
+</p:sld>
+</file>
+
+<file path=ppt/slides/slide10.xml><?xml version="1.0" encoding="utf-8"?>
+<p:sld xmlns:a="http://schemas.openxmlformats.org/drawingml/2006/main" xmlns:r="http://schemas.openxmlformats.org/officeDocument/2006/relationships" xmlns:p="http://schemas.openxmlformats.org/presentationml/2006/main">
+  <p:cSld>
+    <p:spTree>
+      <p:nvGrpSpPr>
+        <p:cNvPr id="1" name="Shape 389"/>
+        <p:cNvGrpSpPr/>
+        <p:nvPr/>
+      </p:nvGrpSpPr>
+      <p:grpSpPr>
+        <a:xfrm>
+          <a:off x="0" y="0"/>
+          <a:ext cx="0" cy="0"/>
+          <a:chOff x="0" y="0"/>
+          <a:chExt cx="0" cy="0"/>
+        </a:xfrm>
+      </p:grpSpPr>
+      <p:sp>
+        <p:nvSpPr>
+          <p:cNvPr id="391" name="Google Shape;391;p19"/>
+          <p:cNvSpPr txBox="1">
+            <a:spLocks noGrp="1"/>
+          </p:cNvSpPr>
+          <p:nvPr>
+            <p:ph type="ctrTitle"/>
+          </p:nvPr>
+        </p:nvSpPr>
+        <p:spPr>
+          <a:xfrm>
+            <a:off x="0" y="-5670"/>
+            <a:ext cx="12192000" cy="990211"/>
+          </a:xfrm>
+          <a:prstGeom prst="rect">
+            <a:avLst/>
+          </a:prstGeom>
+          <a:solidFill>
+            <a:srgbClr val="FF6A0E"/>
+          </a:solidFill>
+          <a:ln w="9525" cap="flat" cmpd="sng">
+            <a:solidFill>
+              <a:srgbClr val="FFFFFF"/>
+            </a:solidFill>
+            <a:prstDash val="solid"/>
+            <a:round/>
+            <a:headEnd type="none" w="sm" len="sm"/>
+            <a:tailEnd type="none" w="sm" len="sm"/>
+          </a:ln>
+        </p:spPr>
+        <p:txBody>
+          <a:bodyPr spcFirstLastPara="1" vert="horz" wrap="square" lIns="121900" tIns="121900" rIns="121900" bIns="121900" rtlCol="0" anchor="t" anchorCtr="0">
+            <a:noAutofit/>
+          </a:bodyPr>
+          <a:lstStyle/>
+          <a:p>
+            <a:pPr marL="599985">
+              <a:lnSpc>
+                <a:spcPct val="150000"/>
+              </a:lnSpc>
+              <a:spcBef>
+                <a:spcPts val="0"/>
+              </a:spcBef>
+              <a:spcAft>
+                <a:spcPts val="2133"/>
+              </a:spcAft>
+            </a:pPr>
+            <a:r>
+              <a:rPr lang="en-GB" sz="4000" b="1" dirty="0">
+                <a:solidFill>
+                  <a:srgbClr val="FFFFFF"/>
+                </a:solidFill>
+                <a:latin typeface="Roboto"/>
+                <a:ea typeface="Roboto"/>
+                <a:cs typeface="Roboto"/>
+                <a:sym typeface="Roboto"/>
+              </a:rPr>
+              <a:t>CONCLUSION</a:t>
+            </a:r>
+          </a:p>
+        </p:txBody>
+      </p:sp>
+      <p:sp>
+        <p:nvSpPr>
+          <p:cNvPr id="392" name="Google Shape;392;p19"/>
+          <p:cNvSpPr txBox="1"/>
+          <p:nvPr/>
+        </p:nvSpPr>
+        <p:spPr>
+          <a:xfrm>
+            <a:off x="-191873" y="720870"/>
+            <a:ext cx="12192000" cy="5416259"/>
+          </a:xfrm>
+          <a:prstGeom prst="rect">
+            <a:avLst/>
+          </a:prstGeom>
+          <a:noFill/>
+          <a:ln>
+            <a:noFill/>
+          </a:ln>
+        </p:spPr>
+        <p:txBody>
+          <a:bodyPr spcFirstLastPara="1" wrap="square" lIns="365733" tIns="365733" rIns="365733" bIns="365733" anchor="t" anchorCtr="0">
+            <a:noAutofit/>
+          </a:bodyPr>
+          <a:lstStyle/>
+          <a:p>
+            <a:pPr marL="895335" indent="-285750" algn="just">
+              <a:spcBef>
+                <a:spcPts val="2133"/>
+              </a:spcBef>
+              <a:spcAft>
+                <a:spcPts val="2133"/>
+              </a:spcAft>
+              <a:buFont typeface="Arial" panose="020B0604020202020204" pitchFamily="34" charset="0"/>
+              <a:buChar char="•"/>
+            </a:pPr>
+            <a:r>
+              <a:rPr lang="en-IN" sz="1600" dirty="0">
+                <a:latin typeface="Roboto" panose="02000000000000000000" pitchFamily="2" charset="0"/>
+                <a:ea typeface="Roboto" panose="02000000000000000000" pitchFamily="2" charset="0"/>
+                <a:cs typeface="Roboto" panose="02000000000000000000" pitchFamily="2" charset="0"/>
+              </a:rPr>
+              <a:t>Shifts maintenance from reactive/fixed-schedule to </a:t>
+            </a:r>
+            <a:r>
+              <a:rPr lang="en-IN" sz="1600" b="1" dirty="0">
+                <a:solidFill>
+                  <a:schemeClr val="accent2"/>
+                </a:solidFill>
+                <a:latin typeface="Roboto" panose="02000000000000000000" pitchFamily="2" charset="0"/>
+                <a:ea typeface="Roboto" panose="02000000000000000000" pitchFamily="2" charset="0"/>
+                <a:cs typeface="Roboto" panose="02000000000000000000" pitchFamily="2" charset="0"/>
+              </a:rPr>
+              <a:t>predictive</a:t>
+            </a:r>
+            <a:r>
+              <a:rPr lang="en-IN" sz="1600" dirty="0">
+                <a:latin typeface="Roboto" panose="02000000000000000000" pitchFamily="2" charset="0"/>
+                <a:ea typeface="Roboto" panose="02000000000000000000" pitchFamily="2" charset="0"/>
+                <a:cs typeface="Roboto" panose="02000000000000000000" pitchFamily="2" charset="0"/>
+              </a:rPr>
+              <a:t> — flagging at-risk machines before they fail, not after </a:t>
+            </a:r>
+          </a:p>
+          <a:p>
+            <a:pPr marL="895335" indent="-285750" algn="just">
+              <a:spcBef>
+                <a:spcPts val="2133"/>
+              </a:spcBef>
+              <a:spcAft>
+                <a:spcPts val="2133"/>
+              </a:spcAft>
+              <a:buFont typeface="Arial" panose="020B0604020202020204" pitchFamily="34" charset="0"/>
+              <a:buChar char="•"/>
+            </a:pPr>
+            <a:r>
+              <a:rPr lang="en-IN" sz="1600" dirty="0">
+                <a:solidFill>
+                  <a:schemeClr val="accent2"/>
+                </a:solidFill>
+                <a:latin typeface="Roboto" panose="02000000000000000000" pitchFamily="2" charset="0"/>
+                <a:ea typeface="Roboto" panose="02000000000000000000" pitchFamily="2" charset="0"/>
+                <a:cs typeface="Roboto" panose="02000000000000000000" pitchFamily="2" charset="0"/>
+              </a:rPr>
+              <a:t>Caught ~82% of real failures </a:t>
+            </a:r>
+            <a:r>
+              <a:rPr lang="en-IN" sz="1600" dirty="0">
+                <a:latin typeface="Roboto" panose="02000000000000000000" pitchFamily="2" charset="0"/>
+                <a:ea typeface="Roboto" panose="02000000000000000000" pitchFamily="2" charset="0"/>
+                <a:cs typeface="Roboto" panose="02000000000000000000" pitchFamily="2" charset="0"/>
+              </a:rPr>
+              <a:t>before occurrence (Recall ≈ 0.82) — most breakdowns no longer need to be a surprise </a:t>
+            </a:r>
+          </a:p>
+          <a:p>
+            <a:pPr marL="895335" indent="-285750" algn="just">
+              <a:spcBef>
+                <a:spcPts val="2133"/>
+              </a:spcBef>
+              <a:spcAft>
+                <a:spcPts val="2133"/>
+              </a:spcAft>
+              <a:buFont typeface="Arial" panose="020B0604020202020204" pitchFamily="34" charset="0"/>
+              <a:buChar char="•"/>
+            </a:pPr>
+            <a:r>
+              <a:rPr lang="en-IN" sz="1600" dirty="0">
+                <a:solidFill>
+                  <a:schemeClr val="accent2"/>
+                </a:solidFill>
+                <a:latin typeface="Roboto" panose="02000000000000000000" pitchFamily="2" charset="0"/>
+                <a:ea typeface="Roboto" panose="02000000000000000000" pitchFamily="2" charset="0"/>
+                <a:cs typeface="Roboto" panose="02000000000000000000" pitchFamily="2" charset="0"/>
+              </a:rPr>
+              <a:t>Reduces unnecessary servicing </a:t>
+            </a:r>
+            <a:r>
+              <a:rPr lang="en-IN" sz="1600" dirty="0">
+                <a:latin typeface="Roboto" panose="02000000000000000000" pitchFamily="2" charset="0"/>
+                <a:ea typeface="Roboto" panose="02000000000000000000" pitchFamily="2" charset="0"/>
+                <a:cs typeface="Roboto" panose="02000000000000000000" pitchFamily="2" charset="0"/>
+              </a:rPr>
+              <a:t>by targeting only flagged machines instead of every machine on a fixed schedule </a:t>
+            </a:r>
+          </a:p>
+          <a:p>
+            <a:pPr marL="895335" indent="-285750" algn="just">
+              <a:spcBef>
+                <a:spcPts val="2133"/>
+              </a:spcBef>
+              <a:spcAft>
+                <a:spcPts val="2133"/>
+              </a:spcAft>
+              <a:buFont typeface="Arial" panose="020B0604020202020204" pitchFamily="34" charset="0"/>
+              <a:buChar char="•"/>
+            </a:pPr>
+            <a:r>
+              <a:rPr lang="en-IN" sz="1600" dirty="0">
+                <a:latin typeface="Roboto" panose="02000000000000000000" pitchFamily="2" charset="0"/>
+                <a:ea typeface="Roboto" panose="02000000000000000000" pitchFamily="2" charset="0"/>
+                <a:cs typeface="Roboto" panose="02000000000000000000" pitchFamily="2" charset="0"/>
+              </a:rPr>
+              <a:t>Failure-type prediction lets technicians arrive with the right part in hand, </a:t>
+            </a:r>
+            <a:r>
+              <a:rPr lang="en-IN" sz="1600" dirty="0">
+                <a:solidFill>
+                  <a:schemeClr val="accent2"/>
+                </a:solidFill>
+                <a:latin typeface="Roboto" panose="02000000000000000000" pitchFamily="2" charset="0"/>
+                <a:ea typeface="Roboto" panose="02000000000000000000" pitchFamily="2" charset="0"/>
+                <a:cs typeface="Roboto" panose="02000000000000000000" pitchFamily="2" charset="0"/>
+              </a:rPr>
+              <a:t>cutting repair time </a:t>
+            </a:r>
+          </a:p>
+          <a:p>
+            <a:pPr marL="895335" indent="-285750" algn="just">
+              <a:spcBef>
+                <a:spcPts val="2133"/>
+              </a:spcBef>
+              <a:spcAft>
+                <a:spcPts val="2133"/>
+              </a:spcAft>
+              <a:buFont typeface="Arial" panose="020B0604020202020204" pitchFamily="34" charset="0"/>
+              <a:buChar char="•"/>
+            </a:pPr>
+            <a:r>
+              <a:rPr lang="en-IN" sz="1600" dirty="0">
+                <a:latin typeface="Roboto" panose="02000000000000000000" pitchFamily="2" charset="0"/>
+                <a:ea typeface="Roboto" panose="02000000000000000000" pitchFamily="2" charset="0"/>
+                <a:cs typeface="Roboto" panose="02000000000000000000" pitchFamily="2" charset="0"/>
+              </a:rPr>
+              <a:t>Trade-off accepted by design: some false alarms (85) vs. missed failures (12) — the right call, since a missed failure costs far more than an unnecessary inspection</a:t>
+            </a:r>
+          </a:p>
+          <a:p>
+            <a:pPr marL="895335" indent="-285750" algn="just">
+              <a:spcBef>
+                <a:spcPts val="2133"/>
+              </a:spcBef>
+              <a:spcAft>
+                <a:spcPts val="2133"/>
+              </a:spcAft>
+              <a:buFont typeface="Arial" panose="020B0604020202020204" pitchFamily="34" charset="0"/>
+              <a:buChar char="•"/>
+            </a:pPr>
+            <a:r>
+              <a:rPr lang="en-IN" sz="1600" b="1" dirty="0">
+                <a:solidFill>
+                  <a:schemeClr val="accent2"/>
+                </a:solidFill>
+                <a:latin typeface="Roboto" panose="02000000000000000000" pitchFamily="2" charset="0"/>
+                <a:ea typeface="Roboto" panose="02000000000000000000" pitchFamily="2" charset="0"/>
+                <a:cs typeface="Roboto" panose="02000000000000000000" pitchFamily="2" charset="0"/>
+              </a:rPr>
+              <a:t>Bottom line:</a:t>
+            </a:r>
+            <a:r>
+              <a:rPr lang="en-IN" sz="1600" dirty="0">
+                <a:solidFill>
+                  <a:schemeClr val="accent2"/>
+                </a:solidFill>
+                <a:latin typeface="Roboto" panose="02000000000000000000" pitchFamily="2" charset="0"/>
+                <a:ea typeface="Roboto" panose="02000000000000000000" pitchFamily="2" charset="0"/>
+                <a:cs typeface="Roboto" panose="02000000000000000000" pitchFamily="2" charset="0"/>
+              </a:rPr>
+              <a:t> </a:t>
+            </a:r>
+            <a:r>
+              <a:rPr lang="en-IN" sz="1600" dirty="0">
+                <a:latin typeface="Roboto" panose="02000000000000000000" pitchFamily="2" charset="0"/>
+                <a:ea typeface="Roboto" panose="02000000000000000000" pitchFamily="2" charset="0"/>
+                <a:cs typeface="Roboto" panose="02000000000000000000" pitchFamily="2" charset="0"/>
+              </a:rPr>
+              <a:t>Converts unpredictable, costly breakdowns into manageable, scheduled interventions — the core value proposition of predictive maintenance</a:t>
+            </a:r>
+            <a:endParaRPr sz="1600" dirty="0">
+              <a:solidFill>
+                <a:schemeClr val="dk1"/>
+              </a:solidFill>
+              <a:latin typeface="Roboto" panose="02000000000000000000" pitchFamily="2" charset="0"/>
+              <a:ea typeface="Roboto" panose="02000000000000000000" pitchFamily="2" charset="0"/>
+              <a:cs typeface="Roboto" panose="02000000000000000000" pitchFamily="2" charset="0"/>
+              <a:sym typeface="Roboto"/>
+            </a:endParaRPr>
+          </a:p>
+        </p:txBody>
+      </p:sp>
+      <p:sp>
+        <p:nvSpPr>
+          <p:cNvPr id="393" name="Google Shape;393;p19"/>
+          <p:cNvSpPr txBox="1"/>
+          <p:nvPr/>
+        </p:nvSpPr>
+        <p:spPr>
+          <a:xfrm>
+            <a:off x="-13400" y="6400800"/>
+            <a:ext cx="12218800" cy="360800"/>
+          </a:xfrm>
+          <a:prstGeom prst="rect">
+            <a:avLst/>
+          </a:prstGeom>
+          <a:solidFill>
+            <a:srgbClr val="FF6A0E"/>
+          </a:solidFill>
+          <a:ln>
+            <a:noFill/>
+          </a:ln>
+        </p:spPr>
+        <p:txBody>
+          <a:bodyPr spcFirstLastPara="1" wrap="square" lIns="121900" tIns="121900" rIns="121900" bIns="121900" anchor="ctr" anchorCtr="0">
+            <a:noAutofit/>
+          </a:bodyPr>
+          <a:lstStyle/>
+          <a:p>
+            <a:pPr marR="243834" algn="r"/>
+            <a:r>
+              <a:rPr lang="en-GB" sz="1200" dirty="0">
+                <a:solidFill>
+                  <a:srgbClr val="FFFFFF"/>
+                </a:solidFill>
+                <a:latin typeface="Roboto"/>
+                <a:ea typeface="Roboto"/>
+                <a:cs typeface="Roboto"/>
+                <a:sym typeface="Roboto"/>
+              </a:rPr>
+              <a:t>© All rights reserved by </a:t>
+            </a:r>
+            <a:r>
+              <a:rPr lang="en-GB" sz="1200" dirty="0" err="1">
+                <a:solidFill>
+                  <a:srgbClr val="FFFFFF"/>
+                </a:solidFill>
+                <a:latin typeface="Roboto"/>
+                <a:ea typeface="Roboto"/>
+                <a:cs typeface="Roboto"/>
+                <a:sym typeface="Roboto"/>
+              </a:rPr>
+              <a:t>Fireblaze</a:t>
+            </a:r>
+            <a:r>
+              <a:rPr lang="en-GB" sz="1200" dirty="0">
+                <a:solidFill>
+                  <a:srgbClr val="FFFFFF"/>
+                </a:solidFill>
+                <a:latin typeface="Roboto"/>
+                <a:ea typeface="Roboto"/>
+                <a:cs typeface="Roboto"/>
+                <a:sym typeface="Roboto"/>
+              </a:rPr>
+              <a:t> Technologies </a:t>
+            </a:r>
+            <a:r>
+              <a:rPr lang="en-GB" sz="1200" dirty="0" err="1">
+                <a:solidFill>
+                  <a:srgbClr val="FFFFFF"/>
+                </a:solidFill>
+                <a:latin typeface="Roboto"/>
+                <a:ea typeface="Roboto"/>
+                <a:cs typeface="Roboto"/>
+                <a:sym typeface="Roboto"/>
+              </a:rPr>
+              <a:t>Pvt.</a:t>
+            </a:r>
+            <a:r>
+              <a:rPr lang="en-GB" sz="1200" dirty="0">
+                <a:solidFill>
+                  <a:srgbClr val="FFFFFF"/>
+                </a:solidFill>
+                <a:latin typeface="Roboto"/>
+                <a:ea typeface="Roboto"/>
+                <a:cs typeface="Roboto"/>
+                <a:sym typeface="Roboto"/>
+              </a:rPr>
+              <a:t> Ltd.</a:t>
+            </a:r>
+            <a:endParaRPr sz="1200" dirty="0">
+              <a:solidFill>
+                <a:srgbClr val="FFFFFF"/>
+              </a:solidFill>
+              <a:latin typeface="Roboto"/>
+              <a:ea typeface="Roboto"/>
+              <a:cs typeface="Roboto"/>
+              <a:sym typeface="Roboto"/>
+            </a:endParaRPr>
+          </a:p>
+        </p:txBody>
+      </p:sp>
+      <p:sp>
+        <p:nvSpPr>
+          <p:cNvPr id="394" name="Google Shape;394;p19"/>
+          <p:cNvSpPr/>
+          <p:nvPr/>
+        </p:nvSpPr>
+        <p:spPr>
+          <a:xfrm rot="10800000">
+            <a:off x="11516800" y="130333"/>
+            <a:ext cx="675200" cy="755200"/>
+          </a:xfrm>
+          <a:prstGeom prst="rtTriangle">
+            <a:avLst/>
+          </a:prstGeom>
+          <a:solidFill>
+            <a:srgbClr val="FF9900"/>
+          </a:solidFill>
+          <a:ln>
+            <a:noFill/>
+          </a:ln>
+        </p:spPr>
+        <p:txBody>
+          <a:bodyPr spcFirstLastPara="1" wrap="square" lIns="121900" tIns="121900" rIns="121900" bIns="121900" anchor="ctr" anchorCtr="0">
+            <a:noAutofit/>
+          </a:bodyPr>
+          <a:lstStyle/>
+          <a:p>
+            <a:endParaRPr sz="2400"/>
+          </a:p>
+        </p:txBody>
+      </p:sp>
+      <p:sp>
+        <p:nvSpPr>
+          <p:cNvPr id="395" name="Google Shape;395;p19"/>
+          <p:cNvSpPr/>
+          <p:nvPr/>
+        </p:nvSpPr>
+        <p:spPr>
+          <a:xfrm>
+            <a:off x="0" y="6400800"/>
+            <a:ext cx="435200" cy="360800"/>
+          </a:xfrm>
+          <a:prstGeom prst="rtTriangle">
+            <a:avLst/>
+          </a:prstGeom>
+          <a:solidFill>
+            <a:srgbClr val="FF9900"/>
+          </a:solidFill>
+          <a:ln>
+            <a:noFill/>
+          </a:ln>
+        </p:spPr>
+        <p:txBody>
+          <a:bodyPr spcFirstLastPara="1" wrap="square" lIns="121900" tIns="121900" rIns="121900" bIns="121900" anchor="ctr" anchorCtr="0">
+            <a:noAutofit/>
+          </a:bodyPr>
+          <a:lstStyle/>
+          <a:p>
+            <a:endParaRPr sz="2400"/>
+          </a:p>
+        </p:txBody>
+      </p:sp>
+    </p:spTree>
+    <p:extLst>
+      <p:ext uri="{BB962C8B-B14F-4D97-AF65-F5344CB8AC3E}">
+        <p14:creationId xmlns:p14="http://schemas.microsoft.com/office/powerpoint/2010/main" val="3374026098"/>
+      </p:ext>
+    </p:extLst>
+  </p:cSld>
+  <p:clrMapOvr>
+    <a:masterClrMapping/>
+  </p:clrMapOvr>
+</p:sld>
+</file>
+
+<file path=ppt/slides/slide11.xml><?xml version="1.0" encoding="utf-8"?>
+<p:sld xmlns:a="http://schemas.openxmlformats.org/drawingml/2006/main" xmlns:r="http://schemas.openxmlformats.org/officeDocument/2006/relationships" xmlns:p="http://schemas.openxmlformats.org/presentationml/2006/main">
+  <p:cSld>
+    <p:spTree>
+      <p:nvGrpSpPr>
+        <p:cNvPr id="1" name="Shape 389"/>
+        <p:cNvGrpSpPr/>
+        <p:nvPr/>
+      </p:nvGrpSpPr>
+      <p:grpSpPr>
+        <a:xfrm>
+          <a:off x="0" y="0"/>
+          <a:ext cx="0" cy="0"/>
+          <a:chOff x="0" y="0"/>
+          <a:chExt cx="0" cy="0"/>
+        </a:xfrm>
+      </p:grpSpPr>
+      <p:sp>
+        <p:nvSpPr>
+          <p:cNvPr id="391" name="Google Shape;391;p19"/>
+          <p:cNvSpPr txBox="1">
+            <a:spLocks noGrp="1"/>
+          </p:cNvSpPr>
+          <p:nvPr>
+            <p:ph type="ctrTitle"/>
+          </p:nvPr>
+        </p:nvSpPr>
+        <p:spPr>
+          <a:xfrm>
+            <a:off x="0" y="-5670"/>
+            <a:ext cx="12192000" cy="990211"/>
+          </a:xfrm>
+          <a:prstGeom prst="rect">
+            <a:avLst/>
+          </a:prstGeom>
+          <a:solidFill>
+            <a:srgbClr val="FF6A0E"/>
+          </a:solidFill>
+          <a:ln w="9525" cap="flat" cmpd="sng">
+            <a:solidFill>
+              <a:srgbClr val="FFFFFF"/>
+            </a:solidFill>
+            <a:prstDash val="solid"/>
+            <a:round/>
+            <a:headEnd type="none" w="sm" len="sm"/>
+            <a:tailEnd type="none" w="sm" len="sm"/>
+          </a:ln>
+        </p:spPr>
+        <p:txBody>
+          <a:bodyPr spcFirstLastPara="1" vert="horz" wrap="square" lIns="121900" tIns="121900" rIns="121900" bIns="121900" rtlCol="0" anchor="t" anchorCtr="0">
+            <a:noAutofit/>
+          </a:bodyPr>
+          <a:lstStyle/>
+          <a:p>
+            <a:pPr marL="599985">
+              <a:lnSpc>
+                <a:spcPct val="150000"/>
+              </a:lnSpc>
+              <a:spcBef>
+                <a:spcPts val="0"/>
+              </a:spcBef>
+              <a:spcAft>
+                <a:spcPts val="2133"/>
+              </a:spcAft>
+            </a:pPr>
+            <a:r>
+              <a:rPr lang="en-GB" sz="4000" b="1" dirty="0">
+                <a:solidFill>
+                  <a:srgbClr val="FFFFFF"/>
+                </a:solidFill>
+                <a:latin typeface="Roboto"/>
+                <a:ea typeface="Roboto"/>
+                <a:cs typeface="Roboto"/>
+                <a:sym typeface="Roboto"/>
+              </a:rPr>
+              <a:t>FUTURE SCOPE</a:t>
+            </a:r>
+          </a:p>
+        </p:txBody>
+      </p:sp>
+      <p:sp>
+        <p:nvSpPr>
+          <p:cNvPr id="392" name="Google Shape;392;p19"/>
+          <p:cNvSpPr txBox="1"/>
+          <p:nvPr/>
+        </p:nvSpPr>
+        <p:spPr>
+          <a:xfrm>
+            <a:off x="217600" y="953535"/>
+            <a:ext cx="12192000" cy="5379265"/>
+          </a:xfrm>
+          <a:prstGeom prst="rect">
+            <a:avLst/>
+          </a:prstGeom>
+          <a:noFill/>
+          <a:ln>
+            <a:noFill/>
+          </a:ln>
+        </p:spPr>
+        <p:txBody>
+          <a:bodyPr spcFirstLastPara="1" wrap="square" lIns="365733" tIns="365733" rIns="365733" bIns="365733" anchor="t" anchorCtr="0">
+            <a:noAutofit/>
+          </a:bodyPr>
+          <a:lstStyle/>
+          <a:p>
+            <a:pPr marL="342900" indent="-342900">
+              <a:lnSpc>
+                <a:spcPct val="200000"/>
+              </a:lnSpc>
+              <a:buFont typeface="Arial" panose="020B0604020202020204" pitchFamily="34" charset="0"/>
+              <a:buChar char="•"/>
+            </a:pPr>
+            <a:r>
+              <a:rPr lang="en-IN" sz="1600" b="1" dirty="0">
+                <a:solidFill>
+                  <a:schemeClr val="accent2"/>
+                </a:solidFill>
+                <a:latin typeface="Roboto" panose="02000000000000000000" pitchFamily="2" charset="0"/>
+                <a:ea typeface="Roboto" panose="02000000000000000000" pitchFamily="2" charset="0"/>
+                <a:cs typeface="Roboto" panose="02000000000000000000" pitchFamily="2" charset="0"/>
+              </a:rPr>
+              <a:t>Live/Streaming Data</a:t>
+            </a:r>
+            <a:r>
+              <a:rPr lang="en-IN" sz="1600" dirty="0">
+                <a:solidFill>
+                  <a:schemeClr val="accent2"/>
+                </a:solidFill>
+                <a:latin typeface="Roboto" panose="02000000000000000000" pitchFamily="2" charset="0"/>
+                <a:ea typeface="Roboto" panose="02000000000000000000" pitchFamily="2" charset="0"/>
+                <a:cs typeface="Roboto" panose="02000000000000000000" pitchFamily="2" charset="0"/>
+              </a:rPr>
+              <a:t> — </a:t>
+            </a:r>
+            <a:r>
+              <a:rPr lang="en-IN" sz="1600" dirty="0">
+                <a:latin typeface="Roboto" panose="02000000000000000000" pitchFamily="2" charset="0"/>
+                <a:ea typeface="Roboto" panose="02000000000000000000" pitchFamily="2" charset="0"/>
+                <a:cs typeface="Roboto" panose="02000000000000000000" pitchFamily="2" charset="0"/>
+              </a:rPr>
+              <a:t>Connect to real sensor feeds via API instead of manual input, allowing predictions to update automatically in real time </a:t>
+            </a:r>
+          </a:p>
+          <a:p>
+            <a:pPr marL="342900" indent="-342900">
+              <a:lnSpc>
+                <a:spcPct val="200000"/>
+              </a:lnSpc>
+              <a:buFont typeface="Arial" panose="020B0604020202020204" pitchFamily="34" charset="0"/>
+              <a:buChar char="•"/>
+            </a:pPr>
+            <a:r>
+              <a:rPr lang="en-IN" sz="1600" b="1" dirty="0">
+                <a:solidFill>
+                  <a:schemeClr val="accent2"/>
+                </a:solidFill>
+                <a:latin typeface="Roboto" panose="02000000000000000000" pitchFamily="2" charset="0"/>
+                <a:ea typeface="Roboto" panose="02000000000000000000" pitchFamily="2" charset="0"/>
+                <a:cs typeface="Roboto" panose="02000000000000000000" pitchFamily="2" charset="0"/>
+              </a:rPr>
+              <a:t>Stronger ML Models</a:t>
+            </a:r>
+            <a:r>
+              <a:rPr lang="en-IN" sz="1600" dirty="0">
+                <a:solidFill>
+                  <a:schemeClr val="accent2"/>
+                </a:solidFill>
+                <a:latin typeface="Roboto" panose="02000000000000000000" pitchFamily="2" charset="0"/>
+                <a:ea typeface="Roboto" panose="02000000000000000000" pitchFamily="2" charset="0"/>
+                <a:cs typeface="Roboto" panose="02000000000000000000" pitchFamily="2" charset="0"/>
+              </a:rPr>
+              <a:t> — </a:t>
+            </a:r>
+            <a:r>
+              <a:rPr lang="en-IN" sz="1600" dirty="0">
+                <a:latin typeface="Roboto" panose="02000000000000000000" pitchFamily="2" charset="0"/>
+                <a:ea typeface="Roboto" panose="02000000000000000000" pitchFamily="2" charset="0"/>
+                <a:cs typeface="Roboto" panose="02000000000000000000" pitchFamily="2" charset="0"/>
+              </a:rPr>
+              <a:t>Test </a:t>
+            </a:r>
+            <a:r>
+              <a:rPr lang="en-IN" sz="1600" dirty="0" err="1">
+                <a:latin typeface="Roboto" panose="02000000000000000000" pitchFamily="2" charset="0"/>
+                <a:ea typeface="Roboto" panose="02000000000000000000" pitchFamily="2" charset="0"/>
+                <a:cs typeface="Roboto" panose="02000000000000000000" pitchFamily="2" charset="0"/>
+              </a:rPr>
+              <a:t>XGBoost</a:t>
+            </a:r>
+            <a:r>
+              <a:rPr lang="en-IN" sz="1600" dirty="0">
+                <a:latin typeface="Roboto" panose="02000000000000000000" pitchFamily="2" charset="0"/>
+                <a:ea typeface="Roboto" panose="02000000000000000000" pitchFamily="2" charset="0"/>
+                <a:cs typeface="Roboto" panose="02000000000000000000" pitchFamily="2" charset="0"/>
+              </a:rPr>
+              <a:t> and </a:t>
+            </a:r>
+            <a:r>
+              <a:rPr lang="en-IN" sz="1600" dirty="0" err="1">
+                <a:latin typeface="Roboto" panose="02000000000000000000" pitchFamily="2" charset="0"/>
+                <a:ea typeface="Roboto" panose="02000000000000000000" pitchFamily="2" charset="0"/>
+                <a:cs typeface="Roboto" panose="02000000000000000000" pitchFamily="2" charset="0"/>
+              </a:rPr>
+              <a:t>LightGBM</a:t>
+            </a:r>
+            <a:r>
+              <a:rPr lang="en-IN" sz="1600" dirty="0">
+                <a:latin typeface="Roboto" panose="02000000000000000000" pitchFamily="2" charset="0"/>
+                <a:ea typeface="Roboto" panose="02000000000000000000" pitchFamily="2" charset="0"/>
+                <a:cs typeface="Roboto" panose="02000000000000000000" pitchFamily="2" charset="0"/>
+              </a:rPr>
+              <a:t>, known to outperform Random Forest on tabular data, for potentially better precision-recall </a:t>
+            </a:r>
+            <a:r>
+              <a:rPr lang="en-IN" sz="1600" dirty="0" err="1">
+                <a:latin typeface="Roboto" panose="02000000000000000000" pitchFamily="2" charset="0"/>
+                <a:ea typeface="Roboto" panose="02000000000000000000" pitchFamily="2" charset="0"/>
+                <a:cs typeface="Roboto" panose="02000000000000000000" pitchFamily="2" charset="0"/>
+              </a:rPr>
+              <a:t>tradeoffs</a:t>
+            </a:r>
+            <a:r>
+              <a:rPr lang="en-IN" sz="1600" dirty="0">
+                <a:latin typeface="Roboto" panose="02000000000000000000" pitchFamily="2" charset="0"/>
+                <a:ea typeface="Roboto" panose="02000000000000000000" pitchFamily="2" charset="0"/>
+                <a:cs typeface="Roboto" panose="02000000000000000000" pitchFamily="2" charset="0"/>
+              </a:rPr>
+              <a:t> </a:t>
+            </a:r>
+          </a:p>
+          <a:p>
+            <a:pPr marL="342900" indent="-342900">
+              <a:lnSpc>
+                <a:spcPct val="200000"/>
+              </a:lnSpc>
+              <a:buFont typeface="Arial" panose="020B0604020202020204" pitchFamily="34" charset="0"/>
+              <a:buChar char="•"/>
+            </a:pPr>
+            <a:r>
+              <a:rPr lang="en-IN" sz="1600" b="1" dirty="0">
+                <a:solidFill>
+                  <a:schemeClr val="accent2"/>
+                </a:solidFill>
+                <a:latin typeface="Roboto" panose="02000000000000000000" pitchFamily="2" charset="0"/>
+                <a:ea typeface="Roboto" panose="02000000000000000000" pitchFamily="2" charset="0"/>
+                <a:cs typeface="Roboto" panose="02000000000000000000" pitchFamily="2" charset="0"/>
+              </a:rPr>
+              <a:t>Historical Trend Dashboard</a:t>
+            </a:r>
+            <a:r>
+              <a:rPr lang="en-IN" sz="1600" dirty="0">
+                <a:solidFill>
+                  <a:schemeClr val="accent2"/>
+                </a:solidFill>
+                <a:latin typeface="Roboto" panose="02000000000000000000" pitchFamily="2" charset="0"/>
+                <a:ea typeface="Roboto" panose="02000000000000000000" pitchFamily="2" charset="0"/>
+                <a:cs typeface="Roboto" panose="02000000000000000000" pitchFamily="2" charset="0"/>
+              </a:rPr>
+              <a:t> — </a:t>
+            </a:r>
+            <a:r>
+              <a:rPr lang="en-IN" sz="1600" dirty="0">
+                <a:latin typeface="Roboto" panose="02000000000000000000" pitchFamily="2" charset="0"/>
+                <a:ea typeface="Roboto" panose="02000000000000000000" pitchFamily="2" charset="0"/>
+                <a:cs typeface="Roboto" panose="02000000000000000000" pitchFamily="2" charset="0"/>
+              </a:rPr>
+              <a:t>Add a tab visualizing a machine's failure-risk trend over time using logged predictions, enabling earlier warning signals </a:t>
+            </a:r>
+          </a:p>
+          <a:p>
+            <a:pPr marL="342900" indent="-342900">
+              <a:lnSpc>
+                <a:spcPct val="200000"/>
+              </a:lnSpc>
+              <a:buFont typeface="Arial" panose="020B0604020202020204" pitchFamily="34" charset="0"/>
+              <a:buChar char="•"/>
+            </a:pPr>
+            <a:r>
+              <a:rPr lang="en-IN" sz="1600" b="1" dirty="0">
+                <a:solidFill>
+                  <a:schemeClr val="accent2"/>
+                </a:solidFill>
+                <a:latin typeface="Roboto" panose="02000000000000000000" pitchFamily="2" charset="0"/>
+                <a:ea typeface="Roboto" panose="02000000000000000000" pitchFamily="2" charset="0"/>
+                <a:cs typeface="Roboto" panose="02000000000000000000" pitchFamily="2" charset="0"/>
+              </a:rPr>
+              <a:t>Automated Alerting System</a:t>
+            </a:r>
+            <a:r>
+              <a:rPr lang="en-IN" sz="1600" dirty="0">
+                <a:solidFill>
+                  <a:schemeClr val="accent2"/>
+                </a:solidFill>
+                <a:latin typeface="Roboto" panose="02000000000000000000" pitchFamily="2" charset="0"/>
+                <a:ea typeface="Roboto" panose="02000000000000000000" pitchFamily="2" charset="0"/>
+                <a:cs typeface="Roboto" panose="02000000000000000000" pitchFamily="2" charset="0"/>
+              </a:rPr>
+              <a:t> — </a:t>
+            </a:r>
+            <a:r>
+              <a:rPr lang="en-IN" sz="1600" dirty="0">
+                <a:latin typeface="Roboto" panose="02000000000000000000" pitchFamily="2" charset="0"/>
+                <a:ea typeface="Roboto" panose="02000000000000000000" pitchFamily="2" charset="0"/>
+                <a:cs typeface="Roboto" panose="02000000000000000000" pitchFamily="2" charset="0"/>
+              </a:rPr>
+              <a:t>Trigger email/notification alerts when predicted failure probability crosses a critical threshold</a:t>
+            </a:r>
+          </a:p>
+          <a:p>
+            <a:pPr marL="342900" indent="-342900">
+              <a:lnSpc>
+                <a:spcPct val="200000"/>
+              </a:lnSpc>
+              <a:buFont typeface="Arial" panose="020B0604020202020204" pitchFamily="34" charset="0"/>
+              <a:buChar char="•"/>
+            </a:pPr>
+            <a:r>
+              <a:rPr lang="en-IN" sz="1600" b="1" dirty="0">
+                <a:solidFill>
+                  <a:schemeClr val="accent2"/>
+                </a:solidFill>
+                <a:latin typeface="Roboto" panose="02000000000000000000" pitchFamily="2" charset="0"/>
+                <a:ea typeface="Roboto" panose="02000000000000000000" pitchFamily="2" charset="0"/>
+                <a:cs typeface="Roboto" panose="02000000000000000000" pitchFamily="2" charset="0"/>
+              </a:rPr>
+              <a:t>Multi-Machine Monitoring View</a:t>
+            </a:r>
+            <a:r>
+              <a:rPr lang="en-IN" sz="1600" dirty="0">
+                <a:solidFill>
+                  <a:schemeClr val="accent2"/>
+                </a:solidFill>
+                <a:latin typeface="Roboto" panose="02000000000000000000" pitchFamily="2" charset="0"/>
+                <a:ea typeface="Roboto" panose="02000000000000000000" pitchFamily="2" charset="0"/>
+                <a:cs typeface="Roboto" panose="02000000000000000000" pitchFamily="2" charset="0"/>
+              </a:rPr>
+              <a:t> — </a:t>
+            </a:r>
+            <a:r>
+              <a:rPr lang="en-IN" sz="1600" dirty="0">
+                <a:latin typeface="Roboto" panose="02000000000000000000" pitchFamily="2" charset="0"/>
+                <a:ea typeface="Roboto" panose="02000000000000000000" pitchFamily="2" charset="0"/>
+                <a:cs typeface="Roboto" panose="02000000000000000000" pitchFamily="2" charset="0"/>
+              </a:rPr>
+              <a:t>Extend from single-machine input to a dashboard tracking multiple machines, sorted by risk level</a:t>
+            </a:r>
+            <a:endParaRPr lang="en-IN" sz="1600" dirty="0">
+              <a:solidFill>
+                <a:schemeClr val="dk1"/>
+              </a:solidFill>
+              <a:latin typeface="Roboto" panose="02000000000000000000" pitchFamily="2" charset="0"/>
+              <a:ea typeface="Roboto" panose="02000000000000000000" pitchFamily="2" charset="0"/>
+              <a:cs typeface="Roboto" panose="02000000000000000000" pitchFamily="2" charset="0"/>
+              <a:sym typeface="Roboto"/>
+            </a:endParaRPr>
+          </a:p>
+        </p:txBody>
+      </p:sp>
+      <p:sp>
+        <p:nvSpPr>
+          <p:cNvPr id="393" name="Google Shape;393;p19"/>
+          <p:cNvSpPr txBox="1"/>
+          <p:nvPr/>
+        </p:nvSpPr>
+        <p:spPr>
+          <a:xfrm>
+            <a:off x="-13400" y="6400800"/>
+            <a:ext cx="12218800" cy="360800"/>
+          </a:xfrm>
+          <a:prstGeom prst="rect">
+            <a:avLst/>
+          </a:prstGeom>
+          <a:solidFill>
+            <a:srgbClr val="FF6A0E"/>
+          </a:solidFill>
+          <a:ln>
+            <a:noFill/>
+          </a:ln>
+        </p:spPr>
+        <p:txBody>
+          <a:bodyPr spcFirstLastPara="1" wrap="square" lIns="121900" tIns="121900" rIns="121900" bIns="121900" anchor="ctr" anchorCtr="0">
+            <a:noAutofit/>
+          </a:bodyPr>
+          <a:lstStyle/>
+          <a:p>
+            <a:pPr marR="243834" algn="r"/>
+            <a:r>
+              <a:rPr lang="en-GB" sz="1200" dirty="0">
+                <a:solidFill>
+                  <a:srgbClr val="FFFFFF"/>
+                </a:solidFill>
+                <a:latin typeface="Roboto"/>
+                <a:ea typeface="Roboto"/>
+                <a:cs typeface="Roboto"/>
+                <a:sym typeface="Roboto"/>
+              </a:rPr>
+              <a:t>© All rights reserved by </a:t>
+            </a:r>
+            <a:r>
+              <a:rPr lang="en-GB" sz="1200" dirty="0" err="1">
+                <a:solidFill>
+                  <a:srgbClr val="FFFFFF"/>
+                </a:solidFill>
+                <a:latin typeface="Roboto"/>
+                <a:ea typeface="Roboto"/>
+                <a:cs typeface="Roboto"/>
+                <a:sym typeface="Roboto"/>
+              </a:rPr>
+              <a:t>Fireblaze</a:t>
+            </a:r>
+            <a:r>
+              <a:rPr lang="en-GB" sz="1200" dirty="0">
+                <a:solidFill>
+                  <a:srgbClr val="FFFFFF"/>
+                </a:solidFill>
+                <a:latin typeface="Roboto"/>
+                <a:ea typeface="Roboto"/>
+                <a:cs typeface="Roboto"/>
+                <a:sym typeface="Roboto"/>
+              </a:rPr>
+              <a:t> Technologies </a:t>
+            </a:r>
+            <a:r>
+              <a:rPr lang="en-GB" sz="1200" dirty="0" err="1">
+                <a:solidFill>
+                  <a:srgbClr val="FFFFFF"/>
+                </a:solidFill>
+                <a:latin typeface="Roboto"/>
+                <a:ea typeface="Roboto"/>
+                <a:cs typeface="Roboto"/>
+                <a:sym typeface="Roboto"/>
+              </a:rPr>
+              <a:t>Pvt.</a:t>
+            </a:r>
+            <a:r>
+              <a:rPr lang="en-GB" sz="1200" dirty="0">
+                <a:solidFill>
+                  <a:srgbClr val="FFFFFF"/>
+                </a:solidFill>
+                <a:latin typeface="Roboto"/>
+                <a:ea typeface="Roboto"/>
+                <a:cs typeface="Roboto"/>
+                <a:sym typeface="Roboto"/>
+              </a:rPr>
+              <a:t> Ltd.</a:t>
+            </a:r>
+            <a:endParaRPr sz="1200" dirty="0">
+              <a:solidFill>
+                <a:srgbClr val="FFFFFF"/>
+              </a:solidFill>
+              <a:latin typeface="Roboto"/>
+              <a:ea typeface="Roboto"/>
+              <a:cs typeface="Roboto"/>
+              <a:sym typeface="Roboto"/>
+            </a:endParaRPr>
+          </a:p>
+        </p:txBody>
+      </p:sp>
+      <p:sp>
+        <p:nvSpPr>
+          <p:cNvPr id="394" name="Google Shape;394;p19"/>
+          <p:cNvSpPr/>
+          <p:nvPr/>
+        </p:nvSpPr>
+        <p:spPr>
+          <a:xfrm rot="10800000">
+            <a:off x="11516800" y="130333"/>
+            <a:ext cx="675200" cy="755200"/>
+          </a:xfrm>
+          <a:prstGeom prst="rtTriangle">
+            <a:avLst/>
+          </a:prstGeom>
+          <a:solidFill>
+            <a:srgbClr val="FF9900"/>
+          </a:solidFill>
+          <a:ln>
+            <a:noFill/>
+          </a:ln>
+        </p:spPr>
+        <p:txBody>
+          <a:bodyPr spcFirstLastPara="1" wrap="square" lIns="121900" tIns="121900" rIns="121900" bIns="121900" anchor="ctr" anchorCtr="0">
+            <a:noAutofit/>
+          </a:bodyPr>
+          <a:lstStyle/>
+          <a:p>
+            <a:endParaRPr sz="2400"/>
+          </a:p>
+        </p:txBody>
+      </p:sp>
+      <p:sp>
+        <p:nvSpPr>
+          <p:cNvPr id="395" name="Google Shape;395;p19"/>
+          <p:cNvSpPr/>
+          <p:nvPr/>
+        </p:nvSpPr>
+        <p:spPr>
+          <a:xfrm>
+            <a:off x="0" y="6400800"/>
+            <a:ext cx="435200" cy="360800"/>
+          </a:xfrm>
+          <a:prstGeom prst="rtTriangle">
+            <a:avLst/>
+          </a:prstGeom>
+          <a:solidFill>
+            <a:srgbClr val="FF9900"/>
+          </a:solidFill>
+          <a:ln>
+            <a:noFill/>
+          </a:ln>
+        </p:spPr>
+        <p:txBody>
+          <a:bodyPr spcFirstLastPara="1" wrap="square" lIns="121900" tIns="121900" rIns="121900" bIns="121900" anchor="ctr" anchorCtr="0">
+            <a:noAutofit/>
+          </a:bodyPr>
+          <a:lstStyle/>
+          <a:p>
+            <a:endParaRPr sz="2400"/>
+          </a:p>
+        </p:txBody>
+      </p:sp>
+    </p:spTree>
+    <p:extLst>
+      <p:ext uri="{BB962C8B-B14F-4D97-AF65-F5344CB8AC3E}">
+        <p14:creationId xmlns:p14="http://schemas.microsoft.com/office/powerpoint/2010/main" val="2220828657"/>
+      </p:ext>
+    </p:extLst>
+  </p:cSld>
+  <p:clrMapOvr>
+    <a:masterClrMapping/>
+  </p:clrMapOvr>
+</p:sld>
+</file>
+
+<file path=ppt/slides/slide12.xml><?xml version="1.0" encoding="utf-8"?>
+<p:sld xmlns:a="http://schemas.openxmlformats.org/drawingml/2006/main" xmlns:r="http://schemas.openxmlformats.org/officeDocument/2006/relationships" xmlns:p="http://schemas.openxmlformats.org/presentationml/2006/main">
+  <p:cSld>
+    <p:spTree>
+      <p:nvGrpSpPr>
+        <p:cNvPr id="1" name=""/>
+        <p:cNvGrpSpPr/>
+        <p:nvPr/>
+      </p:nvGrpSpPr>
+      <p:grpSpPr>
+        <a:xfrm>
+          <a:off x="0" y="0"/>
+          <a:ext cx="0" cy="0"/>
+          <a:chOff x="0" y="0"/>
+          <a:chExt cx="0" cy="0"/>
+        </a:xfrm>
+      </p:grpSpPr>
+      <p:sp>
+        <p:nvSpPr>
+          <p:cNvPr id="2" name="Rectangle 1">
+            <a:extLst>
+              <a:ext uri="{FF2B5EF4-FFF2-40B4-BE49-F238E27FC236}">
+                <a16:creationId xmlns:a16="http://schemas.microsoft.com/office/drawing/2014/main" id="{CC7EC8B5-2771-4873-FEC9-8288D945149F}"/>
+              </a:ext>
+            </a:extLst>
+          </p:cNvPr>
+          <p:cNvSpPr/>
+          <p:nvPr/>
+        </p:nvSpPr>
+        <p:spPr>
+          <a:xfrm>
+            <a:off x="0" y="0"/>
+            <a:ext cx="12191999" cy="6858000"/>
+          </a:xfrm>
+          <a:prstGeom prst="rect">
+            <a:avLst/>
+          </a:prstGeom>
+          <a:solidFill>
+            <a:schemeClr val="accent2"/>
+          </a:solidFill>
+        </p:spPr>
+        <p:style>
+          <a:lnRef idx="2">
+            <a:schemeClr val="accent1">
+              <a:shade val="15000"/>
+            </a:schemeClr>
+          </a:lnRef>
+          <a:fillRef idx="1">
+            <a:schemeClr val="accent1"/>
+          </a:fillRef>
+          <a:effectRef idx="0">
+            <a:schemeClr val="accent1"/>
+          </a:effectRef>
+          <a:fontRef idx="minor">
+            <a:schemeClr val="lt1"/>
+          </a:fontRef>
+        </p:style>
+        <p:txBody>
+          <a:bodyPr rtlCol="0" anchor="ctr"/>
+          <a:lstStyle/>
+          <a:p>
+            <a:pPr algn="ctr"/>
+            <a:r>
+              <a:rPr lang="en-IN" sz="8800" dirty="0">
+                <a:latin typeface="Roboto" panose="02000000000000000000" pitchFamily="2" charset="0"/>
+                <a:ea typeface="Roboto" panose="02000000000000000000" pitchFamily="2" charset="0"/>
+                <a:cs typeface="Roboto" panose="02000000000000000000" pitchFamily="2" charset="0"/>
+              </a:rPr>
+              <a:t>THANK YOU.</a:t>
+            </a:r>
+          </a:p>
+        </p:txBody>
+      </p:sp>
+    </p:spTree>
+    <p:extLst>
+      <p:ext uri="{BB962C8B-B14F-4D97-AF65-F5344CB8AC3E}">
+        <p14:creationId xmlns:p14="http://schemas.microsoft.com/office/powerpoint/2010/main" val="2503391686"/>
       </p:ext>
     </p:extLst>
   </p:cSld>
@@ -4466,13 +6214,190 @@
               </a:buClr>
               <a:buSzPts val="2000"/>
             </a:pPr>
-            <a:endParaRPr sz="2667" dirty="0">
+            <a:r>
+              <a:rPr lang="en-IN" b="1" dirty="0">
+                <a:solidFill>
+                  <a:schemeClr val="accent2"/>
+                </a:solidFill>
+                <a:latin typeface="Roboto" panose="02000000000000000000" pitchFamily="2" charset="0"/>
+                <a:ea typeface="Roboto" panose="02000000000000000000" pitchFamily="2" charset="0"/>
+                <a:cs typeface="Roboto" panose="02000000000000000000" pitchFamily="2" charset="0"/>
+              </a:rPr>
+              <a:t>THE PROBLEM:</a:t>
+            </a:r>
+          </a:p>
+          <a:p>
+            <a:pPr marL="421213" indent="-285750" algn="just">
+              <a:lnSpc>
+                <a:spcPct val="150000"/>
+              </a:lnSpc>
+              <a:buClr>
+                <a:srgbClr val="000000"/>
+              </a:buClr>
+              <a:buSzPts val="2000"/>
+              <a:buFont typeface="Arial" panose="020B0604020202020204" pitchFamily="34" charset="0"/>
+              <a:buChar char="•"/>
+            </a:pPr>
+            <a:r>
+              <a:rPr lang="en-IN" sz="1600" dirty="0">
+                <a:latin typeface="Roboto" panose="02000000000000000000" pitchFamily="2" charset="0"/>
+                <a:ea typeface="Roboto" panose="02000000000000000000" pitchFamily="2" charset="0"/>
+                <a:cs typeface="Roboto" panose="02000000000000000000" pitchFamily="2" charset="0"/>
+              </a:rPr>
+              <a:t>Traditional maintenance approaches are inefficient: reactive maintenance (fix-after-failure) causes unplanned downtime and production loss, while scheduled maintenance often services healthy machines unnecessarily or misses faster-than-expected wear. </a:t>
+            </a:r>
+          </a:p>
+          <a:p>
+            <a:pPr marL="421213" indent="-285750" algn="just">
+              <a:lnSpc>
+                <a:spcPct val="150000"/>
+              </a:lnSpc>
+              <a:buClr>
+                <a:srgbClr val="000000"/>
+              </a:buClr>
+              <a:buSzPts val="2000"/>
+              <a:buFont typeface="Arial" panose="020B0604020202020204" pitchFamily="34" charset="0"/>
+              <a:buChar char="•"/>
+            </a:pPr>
+            <a:r>
+              <a:rPr lang="en-IN" sz="1600" dirty="0">
+                <a:latin typeface="Roboto" panose="02000000000000000000" pitchFamily="2" charset="0"/>
+                <a:ea typeface="Roboto" panose="02000000000000000000" pitchFamily="2" charset="0"/>
+                <a:cs typeface="Roboto" panose="02000000000000000000" pitchFamily="2" charset="0"/>
+              </a:rPr>
+              <a:t>Modern machines generate continuous sensor data (temperature, speed, torque, tool wear); an opportunity to predict failures before they happen instead of guessing on a fixed schedule. </a:t>
+            </a:r>
+          </a:p>
+          <a:p>
+            <a:pPr marL="421213" indent="-285750" algn="just">
+              <a:lnSpc>
+                <a:spcPct val="150000"/>
+              </a:lnSpc>
+              <a:buClr>
+                <a:srgbClr val="000000"/>
+              </a:buClr>
+              <a:buSzPts val="2000"/>
+              <a:buFont typeface="Arial" panose="020B0604020202020204" pitchFamily="34" charset="0"/>
+              <a:buChar char="•"/>
+            </a:pPr>
+            <a:r>
+              <a:rPr lang="en-IN" sz="1600" b="1" dirty="0">
+                <a:solidFill>
+                  <a:schemeClr val="accent2"/>
+                </a:solidFill>
+                <a:latin typeface="Roboto" panose="02000000000000000000" pitchFamily="2" charset="0"/>
+                <a:ea typeface="Roboto" panose="02000000000000000000" pitchFamily="2" charset="0"/>
+                <a:cs typeface="Roboto" panose="02000000000000000000" pitchFamily="2" charset="0"/>
+              </a:rPr>
+              <a:t>Core question this project answers:</a:t>
+            </a:r>
+            <a:r>
+              <a:rPr lang="en-IN" sz="1600" dirty="0">
+                <a:solidFill>
+                  <a:schemeClr val="accent2"/>
+                </a:solidFill>
+                <a:latin typeface="Roboto" panose="02000000000000000000" pitchFamily="2" charset="0"/>
+                <a:ea typeface="Roboto" panose="02000000000000000000" pitchFamily="2" charset="0"/>
+                <a:cs typeface="Roboto" panose="02000000000000000000" pitchFamily="2" charset="0"/>
+              </a:rPr>
+              <a:t> </a:t>
+            </a:r>
+            <a:r>
+              <a:rPr lang="en-IN" sz="1600" dirty="0">
+                <a:latin typeface="Roboto" panose="02000000000000000000" pitchFamily="2" charset="0"/>
+                <a:ea typeface="Roboto" panose="02000000000000000000" pitchFamily="2" charset="0"/>
+                <a:cs typeface="Roboto" panose="02000000000000000000" pitchFamily="2" charset="0"/>
+              </a:rPr>
+              <a:t>Can we use machine sensor readings to </a:t>
+            </a:r>
+          </a:p>
+          <a:p>
+            <a:pPr marL="135463" algn="just">
+              <a:lnSpc>
+                <a:spcPct val="150000"/>
+              </a:lnSpc>
+              <a:buClr>
+                <a:srgbClr val="000000"/>
+              </a:buClr>
+              <a:buSzPts val="2000"/>
+            </a:pPr>
+            <a:r>
+              <a:rPr lang="en-IN" sz="1600" dirty="0">
+                <a:latin typeface="Roboto" panose="02000000000000000000" pitchFamily="2" charset="0"/>
+                <a:ea typeface="Roboto" panose="02000000000000000000" pitchFamily="2" charset="0"/>
+                <a:cs typeface="Roboto" panose="02000000000000000000" pitchFamily="2" charset="0"/>
+              </a:rPr>
+              <a:t>     (1) predict whether a machine is about to fail, and </a:t>
+            </a:r>
+          </a:p>
+          <a:p>
+            <a:pPr marL="135463" algn="just">
+              <a:lnSpc>
+                <a:spcPct val="150000"/>
+              </a:lnSpc>
+              <a:buClr>
+                <a:srgbClr val="000000"/>
+              </a:buClr>
+              <a:buSzPts val="2000"/>
+            </a:pPr>
+            <a:r>
+              <a:rPr lang="en-IN" sz="1600" dirty="0">
+                <a:latin typeface="Roboto" panose="02000000000000000000" pitchFamily="2" charset="0"/>
+                <a:ea typeface="Roboto" panose="02000000000000000000" pitchFamily="2" charset="0"/>
+                <a:cs typeface="Roboto" panose="02000000000000000000" pitchFamily="2" charset="0"/>
+              </a:rPr>
+              <a:t>     (2) if so, identify what type of failure is occurring? </a:t>
+            </a:r>
+          </a:p>
+          <a:p>
+            <a:pPr marL="421213" indent="-285750" algn="just">
+              <a:lnSpc>
+                <a:spcPct val="150000"/>
+              </a:lnSpc>
+              <a:buClr>
+                <a:srgbClr val="000000"/>
+              </a:buClr>
+              <a:buSzPts val="2000"/>
+              <a:buFont typeface="Arial" panose="020B0604020202020204" pitchFamily="34" charset="0"/>
+              <a:buChar char="•"/>
+            </a:pPr>
+            <a:r>
+              <a:rPr lang="en-IN" sz="1600" b="1" dirty="0">
+                <a:solidFill>
+                  <a:schemeClr val="accent2"/>
+                </a:solidFill>
+                <a:latin typeface="Roboto" panose="02000000000000000000" pitchFamily="2" charset="0"/>
+                <a:ea typeface="Roboto" panose="02000000000000000000" pitchFamily="2" charset="0"/>
+                <a:cs typeface="Roboto" panose="02000000000000000000" pitchFamily="2" charset="0"/>
+              </a:rPr>
+              <a:t>Key challenge:</a:t>
+            </a:r>
+            <a:r>
+              <a:rPr lang="en-IN" sz="1600" dirty="0">
+                <a:solidFill>
+                  <a:schemeClr val="accent2"/>
+                </a:solidFill>
+                <a:latin typeface="Roboto" panose="02000000000000000000" pitchFamily="2" charset="0"/>
+                <a:ea typeface="Roboto" panose="02000000000000000000" pitchFamily="2" charset="0"/>
+                <a:cs typeface="Roboto" panose="02000000000000000000" pitchFamily="2" charset="0"/>
+              </a:rPr>
+              <a:t> </a:t>
+            </a:r>
+            <a:r>
+              <a:rPr lang="en-IN" sz="1600" dirty="0">
+                <a:latin typeface="Roboto" panose="02000000000000000000" pitchFamily="2" charset="0"/>
+                <a:ea typeface="Roboto" panose="02000000000000000000" pitchFamily="2" charset="0"/>
+                <a:cs typeface="Roboto" panose="02000000000000000000" pitchFamily="2" charset="0"/>
+              </a:rPr>
+              <a:t>Failures are rare. Only ~3.4% of machines in the dataset actually fail, making this a class-imbalance problem where a "lazy" model could look 96%+ accurate while being completely useless.</a:t>
+            </a:r>
+            <a:endParaRPr sz="1600" dirty="0">
               <a:solidFill>
                 <a:schemeClr val="dk1"/>
               </a:solidFill>
-              <a:latin typeface="Roboto"/>
-              <a:ea typeface="Roboto"/>
-              <a:cs typeface="Roboto"/>
+              <a:latin typeface="Roboto" panose="02000000000000000000" pitchFamily="2" charset="0"/>
+              <a:ea typeface="Roboto" panose="02000000000000000000" pitchFamily="2" charset="0"/>
+              <a:cs typeface="Roboto" panose="02000000000000000000" pitchFamily="2" charset="0"/>
               <a:sym typeface="Roboto"/>
             </a:endParaRPr>
           </a:p>
@@ -5214,17 +7139,25 @@
               </a:spcAft>
             </a:pPr>
             <a:r>
-              <a:rPr lang="en-GB" sz="4000" b="1" dirty="0">
-                <a:solidFill>
-                  <a:srgbClr val="FFFFFF"/>
-                </a:solidFill>
-                <a:latin typeface="Roboto"/>
-                <a:ea typeface="Roboto"/>
-                <a:cs typeface="Roboto"/>
-                <a:sym typeface="Roboto"/>
-              </a:rPr>
-              <a:t>PROPOSED SOLUTION</a:t>
-            </a:r>
+              <a:rPr lang="en-IN" sz="4000" b="1" dirty="0">
+                <a:solidFill>
+                  <a:schemeClr val="bg1"/>
+                </a:solidFill>
+                <a:latin typeface="Roboto" panose="02000000000000000000" pitchFamily="2" charset="0"/>
+                <a:ea typeface="Roboto" panose="02000000000000000000" pitchFamily="2" charset="0"/>
+                <a:cs typeface="Roboto" panose="02000000000000000000" pitchFamily="2" charset="0"/>
+              </a:rPr>
+              <a:t>CLASS IMBALANCE</a:t>
+            </a:r>
+            <a:endParaRPr lang="en-GB" sz="4000" b="1" dirty="0">
+              <a:solidFill>
+                <a:schemeClr val="bg1"/>
+              </a:solidFill>
+              <a:latin typeface="Roboto" panose="02000000000000000000" pitchFamily="2" charset="0"/>
+              <a:ea typeface="Roboto" panose="02000000000000000000" pitchFamily="2" charset="0"/>
+              <a:cs typeface="Roboto" panose="02000000000000000000" pitchFamily="2" charset="0"/>
+              <a:sym typeface="Roboto"/>
+            </a:endParaRPr>
           </a:p>
         </p:txBody>
       </p:sp>
@@ -5236,7 +7169,7 @@
         </p:nvSpPr>
         <p:spPr>
           <a:xfrm>
-            <a:off x="0" y="1069600"/>
+            <a:off x="-13400" y="885534"/>
             <a:ext cx="12192000" cy="5331200"/>
           </a:xfrm>
           <a:prstGeom prst="rect">
@@ -5253,24 +7186,29 @@
           </a:bodyPr>
           <a:lstStyle/>
           <a:p>
-            <a:pPr algn="just">
+            <a:pPr algn="ctr">
               <a:lnSpc>
                 <a:spcPct val="150000"/>
               </a:lnSpc>
-              <a:spcBef>
-                <a:spcPts val="2133"/>
-              </a:spcBef>
-              <a:spcAft>
-                <a:spcPts val="2133"/>
-              </a:spcAft>
             </a:pPr>
-            <a:endParaRPr sz="2667" dirty="0">
+            <a:r>
+              <a:rPr lang="en-IN" b="1" dirty="0">
+                <a:solidFill>
+                  <a:schemeClr val="accent2"/>
+                </a:solidFill>
+                <a:latin typeface="Roboto" panose="02000000000000000000" pitchFamily="2" charset="0"/>
+                <a:ea typeface="Roboto" panose="02000000000000000000" pitchFamily="2" charset="0"/>
+                <a:cs typeface="Roboto" panose="02000000000000000000" pitchFamily="2" charset="0"/>
+              </a:rPr>
+              <a:t>Severe Class Imbalance in the Target Variable</a:t>
+            </a:r>
+            <a:endParaRPr b="1" dirty="0">
               <a:solidFill>
-                <a:schemeClr val="dk1"/>
+                <a:schemeClr val="accent2"/>
               </a:solidFill>
-              <a:latin typeface="Roboto"/>
-              <a:ea typeface="Roboto"/>
-              <a:cs typeface="Roboto"/>
+              <a:latin typeface="Roboto" panose="02000000000000000000" pitchFamily="2" charset="0"/>
+              <a:ea typeface="Roboto" panose="02000000000000000000" pitchFamily="2" charset="0"/>
+              <a:cs typeface="Roboto" panose="02000000000000000000" pitchFamily="2" charset="0"/>
               <a:sym typeface="Roboto"/>
             </a:endParaRPr>
           </a:p>
@@ -5435,6 +7373,129 @@
           <a:lstStyle/>
           <a:p>
             <a:endParaRPr sz="2400"/>
+          </a:p>
+        </p:txBody>
+      </p:sp>
+      <p:pic>
+        <p:nvPicPr>
+          <p:cNvPr id="3" name="Picture 2">
+            <a:extLst>
+              <a:ext uri="{FF2B5EF4-FFF2-40B4-BE49-F238E27FC236}">
+                <a16:creationId xmlns:a16="http://schemas.microsoft.com/office/drawing/2014/main" id="{8254D2B9-A92A-02A2-AC93-451BB0B5274D}"/>
+              </a:ext>
+            </a:extLst>
+          </p:cNvPr>
+          <p:cNvPicPr>
+            <a:picLocks noChangeAspect="1"/>
+          </p:cNvPicPr>
+          <p:nvPr/>
+        </p:nvPicPr>
+        <p:blipFill>
+          <a:blip r:embed="rId3">
+            <a:extLst>
+              <a:ext uri="{28A0092B-C50C-407E-A947-70E740481C1C}">
+                <a14:useLocalDpi xmlns:a14="http://schemas.microsoft.com/office/drawing/2010/main" val="0"/>
+              </a:ext>
+            </a:extLst>
+          </a:blip>
+          <a:stretch>
+            <a:fillRect/>
+          </a:stretch>
+        </p:blipFill>
+        <p:spPr>
+          <a:xfrm>
+            <a:off x="2611497" y="1970724"/>
+            <a:ext cx="6391469" cy="3528952"/>
+          </a:xfrm>
+          <a:prstGeom prst="rect">
+            <a:avLst/>
+          </a:prstGeom>
+          <a:solidFill>
+            <a:srgbClr val="FFFFFF">
+              <a:shade val="85000"/>
+            </a:srgbClr>
+          </a:solidFill>
+          <a:ln w="88900" cap="sq">
+            <a:solidFill>
+              <a:srgbClr val="FFFFFF"/>
+            </a:solidFill>
+            <a:miter lim="800000"/>
+          </a:ln>
+          <a:effectLst>
+            <a:outerShdw blurRad="55000" dist="18000" dir="5400000" algn="tl" rotWithShape="0">
+              <a:srgbClr val="000000">
+                <a:alpha val="40000"/>
+              </a:srgbClr>
+            </a:outerShdw>
+          </a:effectLst>
+          <a:scene3d>
+            <a:camera prst="orthographicFront"/>
+            <a:lightRig rig="twoPt" dir="t">
+              <a:rot lat="0" lon="0" rev="7200000"/>
+            </a:lightRig>
+          </a:scene3d>
+          <a:sp3d>
+            <a:bevelT w="25400" h="19050"/>
+            <a:contourClr>
+              <a:srgbClr val="FFFFFF"/>
+            </a:contourClr>
+          </a:sp3d>
+        </p:spPr>
+      </p:pic>
+      <p:sp>
+        <p:nvSpPr>
+          <p:cNvPr id="4" name="TextBox 3">
+            <a:extLst>
+              <a:ext uri="{FF2B5EF4-FFF2-40B4-BE49-F238E27FC236}">
+                <a16:creationId xmlns:a16="http://schemas.microsoft.com/office/drawing/2014/main" id="{3BDCA4CE-4237-A841-535C-487B7FDDF1F8}"/>
+              </a:ext>
+            </a:extLst>
+          </p:cNvPr>
+          <p:cNvSpPr txBox="1"/>
+          <p:nvPr/>
+        </p:nvSpPr>
+        <p:spPr>
+          <a:xfrm>
+            <a:off x="1950840" y="5719405"/>
+            <a:ext cx="9903560" cy="461665"/>
+          </a:xfrm>
+          <a:prstGeom prst="rect">
+            <a:avLst/>
+          </a:prstGeom>
+          <a:noFill/>
+        </p:spPr>
+        <p:txBody>
+          <a:bodyPr wrap="square" rtlCol="0">
+            <a:spAutoFit/>
+          </a:bodyPr>
+          <a:lstStyle/>
+          <a:p>
+            <a:pPr marL="285750" indent="-285750">
+              <a:buFont typeface="Arial" panose="020B0604020202020204" pitchFamily="34" charset="0"/>
+              <a:buChar char="•"/>
+            </a:pPr>
+            <a:r>
+              <a:rPr lang="en-IN" sz="1200" dirty="0">
+                <a:latin typeface="Roboto" panose="02000000000000000000" pitchFamily="2" charset="0"/>
+                <a:ea typeface="Roboto" panose="02000000000000000000" pitchFamily="2" charset="0"/>
+                <a:cs typeface="Roboto" panose="02000000000000000000" pitchFamily="2" charset="0"/>
+              </a:rPr>
+              <a:t>Only ~339 of 10,000 machines (3.4%) failed, making this a severely imbalanced classification problem </a:t>
+            </a:r>
+          </a:p>
+          <a:p>
+            <a:pPr marL="285750" indent="-285750">
+              <a:buFont typeface="Arial" panose="020B0604020202020204" pitchFamily="34" charset="0"/>
+              <a:buChar char="•"/>
+            </a:pPr>
+            <a:r>
+              <a:rPr lang="en-IN" sz="1200" dirty="0">
+                <a:latin typeface="Roboto" panose="02000000000000000000" pitchFamily="2" charset="0"/>
+                <a:ea typeface="Roboto" panose="02000000000000000000" pitchFamily="2" charset="0"/>
+                <a:cs typeface="Roboto" panose="02000000000000000000" pitchFamily="2" charset="0"/>
+              </a:rPr>
+              <a:t>A model that always predicts "no failure" would still score ~97% accuracy — proving that accuracy alone is the wrong metric here</a:t>
+            </a:r>
           </a:p>
         </p:txBody>
       </p:sp>
@@ -5456,7 +7517,13 @@
   <p:cSld>
     <p:spTree>
       <p:nvGrpSpPr>
-        <p:cNvPr id="1" name="Shape 389"/>
+        <p:cNvPr id="1" name="Shape 349">
+          <a:extLst>
+            <a:ext uri="{FF2B5EF4-FFF2-40B4-BE49-F238E27FC236}">
+              <a16:creationId xmlns:a16="http://schemas.microsoft.com/office/drawing/2014/main" id="{7D26359C-AF3E-1C7D-27ED-D0127F543FAD}"/>
+            </a:ext>
+          </a:extLst>
+        </p:cNvPr>
         <p:cNvGrpSpPr/>
         <p:nvPr/>
       </p:nvGrpSpPr>
@@ -5470,7 +7537,13 @@
       </p:grpSpPr>
       <p:sp>
         <p:nvSpPr>
-          <p:cNvPr id="391" name="Google Shape;391;p19"/>
+          <p:cNvPr id="351" name="Google Shape;351;p15">
+            <a:extLst>
+              <a:ext uri="{FF2B5EF4-FFF2-40B4-BE49-F238E27FC236}">
+                <a16:creationId xmlns:a16="http://schemas.microsoft.com/office/drawing/2014/main" id="{448E93FC-2EA2-3FC7-A074-F11FDFED4557}"/>
+              </a:ext>
+            </a:extLst>
+          </p:cNvPr>
           <p:cNvSpPr txBox="1">
             <a:spLocks noGrp="1"/>
           </p:cNvSpPr>
@@ -5480,7 +7553,7 @@
         </p:nvSpPr>
         <p:spPr>
           <a:xfrm>
-            <a:off x="0" y="-5670"/>
+            <a:off x="0" y="0"/>
             <a:ext cx="12192000" cy="990211"/>
           </a:xfrm>
           <a:prstGeom prst="rect">
@@ -5517,30 +7590,44 @@
               </a:spcAft>
             </a:pPr>
             <a:r>
-              <a:rPr lang="en-GB" sz="4000" b="1" dirty="0">
-                <a:solidFill>
-                  <a:srgbClr val="FFFFFF"/>
-                </a:solidFill>
-                <a:latin typeface="Roboto"/>
-                <a:ea typeface="Roboto"/>
-                <a:cs typeface="Roboto"/>
-                <a:sym typeface="Roboto"/>
-              </a:rPr>
-              <a:t>CONCLUSION</a:t>
-            </a:r>
-          </a:p>
-        </p:txBody>
-      </p:sp>
-      <p:sp>
-        <p:nvSpPr>
-          <p:cNvPr id="392" name="Google Shape;392;p19"/>
+              <a:rPr lang="en-IN" sz="4000" b="1" dirty="0">
+                <a:solidFill>
+                  <a:schemeClr val="bg1"/>
+                </a:solidFill>
+                <a:latin typeface="Roboto" panose="02000000000000000000" pitchFamily="2" charset="0"/>
+                <a:ea typeface="Roboto" panose="02000000000000000000" pitchFamily="2" charset="0"/>
+                <a:cs typeface="Roboto" panose="02000000000000000000" pitchFamily="2" charset="0"/>
+              </a:rPr>
+              <a:t>FAILURE TYPE BREAKDOWN</a:t>
+            </a:r>
+            <a:endParaRPr lang="en-GB" sz="4000" b="1" dirty="0">
+              <a:solidFill>
+                <a:schemeClr val="bg1"/>
+              </a:solidFill>
+              <a:latin typeface="Roboto" panose="02000000000000000000" pitchFamily="2" charset="0"/>
+              <a:ea typeface="Roboto" panose="02000000000000000000" pitchFamily="2" charset="0"/>
+              <a:cs typeface="Roboto" panose="02000000000000000000" pitchFamily="2" charset="0"/>
+              <a:sym typeface="Roboto"/>
+            </a:endParaRPr>
+          </a:p>
+        </p:txBody>
+      </p:sp>
+      <p:sp>
+        <p:nvSpPr>
+          <p:cNvPr id="352" name="Google Shape;352;p15">
+            <a:extLst>
+              <a:ext uri="{FF2B5EF4-FFF2-40B4-BE49-F238E27FC236}">
+                <a16:creationId xmlns:a16="http://schemas.microsoft.com/office/drawing/2014/main" id="{968D8B4D-EB04-4DC4-4AF6-1B4EC33BEC83}"/>
+              </a:ext>
+            </a:extLst>
+          </p:cNvPr>
           <p:cNvSpPr txBox="1"/>
           <p:nvPr/>
         </p:nvSpPr>
         <p:spPr>
           <a:xfrm>
-            <a:off x="13400" y="984541"/>
-            <a:ext cx="12192000" cy="5416259"/>
+            <a:off x="0" y="951201"/>
+            <a:ext cx="12192000" cy="5331200"/>
           </a:xfrm>
           <a:prstGeom prst="rect">
             <a:avLst/>
@@ -5556,24 +7643,29 @@
           </a:bodyPr>
           <a:lstStyle/>
           <a:p>
-            <a:pPr marL="609585" algn="just">
+            <a:pPr algn="ctr">
               <a:lnSpc>
                 <a:spcPct val="150000"/>
               </a:lnSpc>
-              <a:spcBef>
-                <a:spcPts val="2133"/>
-              </a:spcBef>
-              <a:spcAft>
-                <a:spcPts val="2133"/>
-              </a:spcAft>
             </a:pPr>
-            <a:endParaRPr sz="2667" dirty="0">
+            <a:r>
+              <a:rPr lang="en-IN" b="1" dirty="0">
+                <a:solidFill>
+                  <a:schemeClr val="accent2"/>
+                </a:solidFill>
+                <a:latin typeface="Roboto" panose="02000000000000000000" pitchFamily="2" charset="0"/>
+                <a:ea typeface="Roboto" panose="02000000000000000000" pitchFamily="2" charset="0"/>
+                <a:cs typeface="Roboto" panose="02000000000000000000" pitchFamily="2" charset="0"/>
+              </a:rPr>
+              <a:t>Heat Dissipation is the Most Common Failure Mode</a:t>
+            </a:r>
+            <a:endParaRPr b="1" dirty="0">
               <a:solidFill>
-                <a:schemeClr val="dk1"/>
+                <a:schemeClr val="accent2"/>
               </a:solidFill>
-              <a:latin typeface="Roboto"/>
-              <a:ea typeface="Roboto"/>
-              <a:cs typeface="Roboto"/>
+              <a:latin typeface="Roboto" panose="02000000000000000000" pitchFamily="2" charset="0"/>
+              <a:ea typeface="Roboto" panose="02000000000000000000" pitchFamily="2" charset="0"/>
+              <a:cs typeface="Roboto" panose="02000000000000000000" pitchFamily="2" charset="0"/>
               <a:sym typeface="Roboto"/>
             </a:endParaRPr>
           </a:p>
@@ -5581,7 +7673,13 @@
       </p:sp>
       <p:sp>
         <p:nvSpPr>
-          <p:cNvPr id="393" name="Google Shape;393;p19"/>
+          <p:cNvPr id="353" name="Google Shape;353;p15">
+            <a:extLst>
+              <a:ext uri="{FF2B5EF4-FFF2-40B4-BE49-F238E27FC236}">
+                <a16:creationId xmlns:a16="http://schemas.microsoft.com/office/drawing/2014/main" id="{8C2D2917-5B66-597D-F700-A3E49C7DF87A}"/>
+              </a:ext>
+            </a:extLst>
+          </p:cNvPr>
           <p:cNvSpPr txBox="1"/>
           <p:nvPr/>
         </p:nvSpPr>
@@ -5681,7 +7779,13 @@
       </p:sp>
       <p:sp>
         <p:nvSpPr>
-          <p:cNvPr id="394" name="Google Shape;394;p19"/>
+          <p:cNvPr id="354" name="Google Shape;354;p15">
+            <a:extLst>
+              <a:ext uri="{FF2B5EF4-FFF2-40B4-BE49-F238E27FC236}">
+                <a16:creationId xmlns:a16="http://schemas.microsoft.com/office/drawing/2014/main" id="{02F4FA2A-70CF-28F8-8DA2-1BC4F9FE5719}"/>
+              </a:ext>
+            </a:extLst>
+          </p:cNvPr>
           <p:cNvSpPr/>
           <p:nvPr/>
         </p:nvSpPr>
@@ -5712,7 +7816,13 @@
       </p:sp>
       <p:sp>
         <p:nvSpPr>
-          <p:cNvPr id="395" name="Google Shape;395;p19"/>
+          <p:cNvPr id="355" name="Google Shape;355;p15">
+            <a:extLst>
+              <a:ext uri="{FF2B5EF4-FFF2-40B4-BE49-F238E27FC236}">
+                <a16:creationId xmlns:a16="http://schemas.microsoft.com/office/drawing/2014/main" id="{7C6084A7-AA18-28FC-F88D-0FA7C3A1CA8B}"/>
+              </a:ext>
+            </a:extLst>
+          </p:cNvPr>
           <p:cNvSpPr/>
           <p:nvPr/>
         </p:nvSpPr>
@@ -5741,10 +7851,133 @@
           </a:p>
         </p:txBody>
       </p:sp>
+      <p:pic>
+        <p:nvPicPr>
+          <p:cNvPr id="4" name="Picture 3">
+            <a:extLst>
+              <a:ext uri="{FF2B5EF4-FFF2-40B4-BE49-F238E27FC236}">
+                <a16:creationId xmlns:a16="http://schemas.microsoft.com/office/drawing/2014/main" id="{3EF53447-E38F-95D5-0495-76C8157346F1}"/>
+              </a:ext>
+            </a:extLst>
+          </p:cNvPr>
+          <p:cNvPicPr>
+            <a:picLocks noChangeAspect="1"/>
+          </p:cNvPicPr>
+          <p:nvPr/>
+        </p:nvPicPr>
+        <p:blipFill>
+          <a:blip r:embed="rId3">
+            <a:extLst>
+              <a:ext uri="{28A0092B-C50C-407E-A947-70E740481C1C}">
+                <a14:useLocalDpi xmlns:a14="http://schemas.microsoft.com/office/drawing/2010/main" val="0"/>
+              </a:ext>
+            </a:extLst>
+          </a:blip>
+          <a:stretch>
+            <a:fillRect/>
+          </a:stretch>
+        </p:blipFill>
+        <p:spPr>
+          <a:xfrm>
+            <a:off x="2929812" y="2034070"/>
+            <a:ext cx="6503437" cy="3685595"/>
+          </a:xfrm>
+          <a:prstGeom prst="rect">
+            <a:avLst/>
+          </a:prstGeom>
+          <a:solidFill>
+            <a:srgbClr val="FFFFFF">
+              <a:shade val="85000"/>
+            </a:srgbClr>
+          </a:solidFill>
+          <a:ln w="88900" cap="sq">
+            <a:solidFill>
+              <a:srgbClr val="FFFFFF"/>
+            </a:solidFill>
+            <a:miter lim="800000"/>
+          </a:ln>
+          <a:effectLst>
+            <a:outerShdw blurRad="55000" dist="18000" dir="5400000" algn="tl" rotWithShape="0">
+              <a:srgbClr val="000000">
+                <a:alpha val="40000"/>
+              </a:srgbClr>
+            </a:outerShdw>
+          </a:effectLst>
+          <a:scene3d>
+            <a:camera prst="orthographicFront"/>
+            <a:lightRig rig="twoPt" dir="t">
+              <a:rot lat="0" lon="0" rev="7200000"/>
+            </a:lightRig>
+          </a:scene3d>
+          <a:sp3d>
+            <a:bevelT w="25400" h="19050"/>
+            <a:contourClr>
+              <a:srgbClr val="FFFFFF"/>
+            </a:contourClr>
+          </a:sp3d>
+        </p:spPr>
+      </p:pic>
+      <p:sp>
+        <p:nvSpPr>
+          <p:cNvPr id="5" name="TextBox 4">
+            <a:extLst>
+              <a:ext uri="{FF2B5EF4-FFF2-40B4-BE49-F238E27FC236}">
+                <a16:creationId xmlns:a16="http://schemas.microsoft.com/office/drawing/2014/main" id="{DA6D2047-301E-32AD-68D6-B9E7DB5E5362}"/>
+              </a:ext>
+            </a:extLst>
+          </p:cNvPr>
+          <p:cNvSpPr txBox="1"/>
+          <p:nvPr/>
+        </p:nvSpPr>
+        <p:spPr>
+          <a:xfrm>
+            <a:off x="1826327" y="5838064"/>
+            <a:ext cx="9690473" cy="461665"/>
+          </a:xfrm>
+          <a:prstGeom prst="rect">
+            <a:avLst/>
+          </a:prstGeom>
+          <a:noFill/>
+        </p:spPr>
+        <p:txBody>
+          <a:bodyPr wrap="none" rtlCol="0">
+            <a:spAutoFit/>
+          </a:bodyPr>
+          <a:lstStyle/>
+          <a:p>
+            <a:pPr marL="285750" indent="-285750">
+              <a:buFont typeface="Arial" panose="020B0604020202020204" pitchFamily="34" charset="0"/>
+              <a:buChar char="•"/>
+            </a:pPr>
+            <a:r>
+              <a:rPr lang="en-IN" sz="1200" dirty="0">
+                <a:latin typeface="Roboto" panose="02000000000000000000" pitchFamily="2" charset="0"/>
+                <a:ea typeface="Roboto" panose="02000000000000000000" pitchFamily="2" charset="0"/>
+                <a:cs typeface="Roboto" panose="02000000000000000000" pitchFamily="2" charset="0"/>
+              </a:rPr>
+              <a:t>Heat Dissipation (HDF) is the most common failure mode (~115 cases), followed by Overstrain (OSF) and Power Failure (PWF) </a:t>
+            </a:r>
+          </a:p>
+          <a:p>
+            <a:pPr marL="285750" indent="-285750">
+              <a:buFont typeface="Arial" panose="020B0604020202020204" pitchFamily="34" charset="0"/>
+              <a:buChar char="•"/>
+            </a:pPr>
+            <a:r>
+              <a:rPr lang="en-IN" sz="1200" dirty="0">
+                <a:latin typeface="Roboto" panose="02000000000000000000" pitchFamily="2" charset="0"/>
+                <a:ea typeface="Roboto" panose="02000000000000000000" pitchFamily="2" charset="0"/>
+                <a:cs typeface="Roboto" panose="02000000000000000000" pitchFamily="2" charset="0"/>
+              </a:rPr>
+              <a:t>Random Failure (RNF) is the rarest (~19 cases) by design — it has no detectable sensor pattern, representing real-world unpredictability</a:t>
+            </a:r>
+          </a:p>
+        </p:txBody>
+      </p:sp>
     </p:spTree>
     <p:extLst>
       <p:ext uri="{BB962C8B-B14F-4D97-AF65-F5344CB8AC3E}">
-        <p14:creationId xmlns:p14="http://schemas.microsoft.com/office/powerpoint/2010/main" val="3374026098"/>
+        <p14:creationId xmlns:p14="http://schemas.microsoft.com/office/powerpoint/2010/main" val="1071713488"/>
       </p:ext>
     </p:extLst>
   </p:cSld>
@@ -5759,7 +7992,13 @@
   <p:cSld>
     <p:spTree>
       <p:nvGrpSpPr>
-        <p:cNvPr id="1" name="Shape 389"/>
+        <p:cNvPr id="1" name="Shape 349">
+          <a:extLst>
+            <a:ext uri="{FF2B5EF4-FFF2-40B4-BE49-F238E27FC236}">
+              <a16:creationId xmlns:a16="http://schemas.microsoft.com/office/drawing/2014/main" id="{312F3B6F-9A92-26D9-EC0D-184DE5E8AC96}"/>
+            </a:ext>
+          </a:extLst>
+        </p:cNvPr>
         <p:cNvGrpSpPr/>
         <p:nvPr/>
       </p:nvGrpSpPr>
@@ -5773,7 +8012,13 @@
       </p:grpSpPr>
       <p:sp>
         <p:nvSpPr>
-          <p:cNvPr id="391" name="Google Shape;391;p19"/>
+          <p:cNvPr id="351" name="Google Shape;351;p15">
+            <a:extLst>
+              <a:ext uri="{FF2B5EF4-FFF2-40B4-BE49-F238E27FC236}">
+                <a16:creationId xmlns:a16="http://schemas.microsoft.com/office/drawing/2014/main" id="{DBBA9D2A-03F7-3791-EB22-2A118A9E6892}"/>
+              </a:ext>
+            </a:extLst>
+          </p:cNvPr>
           <p:cNvSpPr txBox="1">
             <a:spLocks noGrp="1"/>
           </p:cNvSpPr>
@@ -5783,7 +8028,7 @@
         </p:nvSpPr>
         <p:spPr>
           <a:xfrm>
-            <a:off x="0" y="-5670"/>
+            <a:off x="0" y="0"/>
             <a:ext cx="12192000" cy="990211"/>
           </a:xfrm>
           <a:prstGeom prst="rect">
@@ -5820,30 +8065,44 @@
               </a:spcAft>
             </a:pPr>
             <a:r>
-              <a:rPr lang="en-GB" sz="4000" b="1" dirty="0">
-                <a:solidFill>
-                  <a:srgbClr val="FFFFFF"/>
-                </a:solidFill>
-                <a:latin typeface="Roboto"/>
-                <a:ea typeface="Roboto"/>
-                <a:cs typeface="Roboto"/>
-                <a:sym typeface="Roboto"/>
-              </a:rPr>
-              <a:t>FUTURE SCOPE</a:t>
-            </a:r>
-          </a:p>
-        </p:txBody>
-      </p:sp>
-      <p:sp>
-        <p:nvSpPr>
-          <p:cNvPr id="392" name="Google Shape;392;p19"/>
+              <a:rPr lang="en-IN" sz="4000" b="1" dirty="0">
+                <a:solidFill>
+                  <a:schemeClr val="bg1"/>
+                </a:solidFill>
+                <a:latin typeface="Roboto" panose="02000000000000000000" pitchFamily="2" charset="0"/>
+                <a:ea typeface="Roboto" panose="02000000000000000000" pitchFamily="2" charset="0"/>
+                <a:cs typeface="Roboto" panose="02000000000000000000" pitchFamily="2" charset="0"/>
+              </a:rPr>
+              <a:t>MODEL COMPARISON</a:t>
+            </a:r>
+            <a:endParaRPr lang="en-GB" sz="4000" b="1" dirty="0">
+              <a:solidFill>
+                <a:schemeClr val="bg1"/>
+              </a:solidFill>
+              <a:latin typeface="Roboto" panose="02000000000000000000" pitchFamily="2" charset="0"/>
+              <a:ea typeface="Roboto" panose="02000000000000000000" pitchFamily="2" charset="0"/>
+              <a:cs typeface="Roboto" panose="02000000000000000000" pitchFamily="2" charset="0"/>
+              <a:sym typeface="Roboto"/>
+            </a:endParaRPr>
+          </a:p>
+        </p:txBody>
+      </p:sp>
+      <p:sp>
+        <p:nvSpPr>
+          <p:cNvPr id="352" name="Google Shape;352;p15">
+            <a:extLst>
+              <a:ext uri="{FF2B5EF4-FFF2-40B4-BE49-F238E27FC236}">
+                <a16:creationId xmlns:a16="http://schemas.microsoft.com/office/drawing/2014/main" id="{1307BDEE-A26F-952D-E657-D2536BCBF5EB}"/>
+              </a:ext>
+            </a:extLst>
+          </p:cNvPr>
           <p:cNvSpPr txBox="1"/>
           <p:nvPr/>
         </p:nvSpPr>
         <p:spPr>
           <a:xfrm>
-            <a:off x="0" y="1021534"/>
-            <a:ext cx="12192000" cy="5379265"/>
+            <a:off x="102637" y="885534"/>
+            <a:ext cx="12192000" cy="5331200"/>
           </a:xfrm>
           <a:prstGeom prst="rect">
             <a:avLst/>
@@ -5859,24 +8118,29 @@
           </a:bodyPr>
           <a:lstStyle/>
           <a:p>
-            <a:pPr marL="609585" algn="just">
+            <a:pPr algn="ctr">
               <a:lnSpc>
                 <a:spcPct val="150000"/>
               </a:lnSpc>
-              <a:spcBef>
-                <a:spcPts val="2133"/>
-              </a:spcBef>
-              <a:spcAft>
-                <a:spcPts val="2133"/>
-              </a:spcAft>
             </a:pPr>
-            <a:endParaRPr sz="2667" dirty="0">
+            <a:r>
+              <a:rPr lang="en-IN" b="1" dirty="0">
+                <a:solidFill>
+                  <a:schemeClr val="accent2"/>
+                </a:solidFill>
+                <a:latin typeface="Roboto" panose="02000000000000000000" pitchFamily="2" charset="0"/>
+                <a:ea typeface="Roboto" panose="02000000000000000000" pitchFamily="2" charset="0"/>
+                <a:cs typeface="Roboto" panose="02000000000000000000" pitchFamily="2" charset="0"/>
+              </a:rPr>
+              <a:t>Random Forest Delivers the Best Overall Balance</a:t>
+            </a:r>
+            <a:endParaRPr b="1" dirty="0">
               <a:solidFill>
-                <a:schemeClr val="dk1"/>
+                <a:schemeClr val="accent2"/>
               </a:solidFill>
-              <a:latin typeface="Roboto"/>
-              <a:ea typeface="Roboto"/>
-              <a:cs typeface="Roboto"/>
+              <a:latin typeface="Roboto" panose="02000000000000000000" pitchFamily="2" charset="0"/>
+              <a:ea typeface="Roboto" panose="02000000000000000000" pitchFamily="2" charset="0"/>
+              <a:cs typeface="Roboto" panose="02000000000000000000" pitchFamily="2" charset="0"/>
               <a:sym typeface="Roboto"/>
             </a:endParaRPr>
           </a:p>
@@ -5884,7 +8148,13 @@
       </p:sp>
       <p:sp>
         <p:nvSpPr>
-          <p:cNvPr id="393" name="Google Shape;393;p19"/>
+          <p:cNvPr id="353" name="Google Shape;353;p15">
+            <a:extLst>
+              <a:ext uri="{FF2B5EF4-FFF2-40B4-BE49-F238E27FC236}">
+                <a16:creationId xmlns:a16="http://schemas.microsoft.com/office/drawing/2014/main" id="{A40A29F6-86A8-3CB6-916A-F7977C525919}"/>
+              </a:ext>
+            </a:extLst>
+          </p:cNvPr>
           <p:cNvSpPr txBox="1"/>
           <p:nvPr/>
         </p:nvSpPr>
@@ -5984,7 +8254,13 @@
       </p:sp>
       <p:sp>
         <p:nvSpPr>
-          <p:cNvPr id="394" name="Google Shape;394;p19"/>
+          <p:cNvPr id="354" name="Google Shape;354;p15">
+            <a:extLst>
+              <a:ext uri="{FF2B5EF4-FFF2-40B4-BE49-F238E27FC236}">
+                <a16:creationId xmlns:a16="http://schemas.microsoft.com/office/drawing/2014/main" id="{C57EC967-3E3D-9096-18E0-0405AE99CC9E}"/>
+              </a:ext>
+            </a:extLst>
+          </p:cNvPr>
           <p:cNvSpPr/>
           <p:nvPr/>
         </p:nvSpPr>
@@ -6015,7 +8291,13 @@
       </p:sp>
       <p:sp>
         <p:nvSpPr>
-          <p:cNvPr id="395" name="Google Shape;395;p19"/>
+          <p:cNvPr id="355" name="Google Shape;355;p15">
+            <a:extLst>
+              <a:ext uri="{FF2B5EF4-FFF2-40B4-BE49-F238E27FC236}">
+                <a16:creationId xmlns:a16="http://schemas.microsoft.com/office/drawing/2014/main" id="{238DE82C-2497-B919-0F5B-CE02690B74EC}"/>
+              </a:ext>
+            </a:extLst>
+          </p:cNvPr>
           <p:cNvSpPr/>
           <p:nvPr/>
         </p:nvSpPr>
@@ -6044,10 +8326,1413 @@
           </a:p>
         </p:txBody>
       </p:sp>
+      <p:pic>
+        <p:nvPicPr>
+          <p:cNvPr id="6" name="Picture 5">
+            <a:extLst>
+              <a:ext uri="{FF2B5EF4-FFF2-40B4-BE49-F238E27FC236}">
+                <a16:creationId xmlns:a16="http://schemas.microsoft.com/office/drawing/2014/main" id="{EFA3688B-DFA4-31ED-C682-6FB43BA6A8B3}"/>
+              </a:ext>
+            </a:extLst>
+          </p:cNvPr>
+          <p:cNvPicPr>
+            <a:picLocks noChangeAspect="1"/>
+          </p:cNvPicPr>
+          <p:nvPr/>
+        </p:nvPicPr>
+        <p:blipFill>
+          <a:blip r:embed="rId3">
+            <a:extLst>
+              <a:ext uri="{28A0092B-C50C-407E-A947-70E740481C1C}">
+                <a14:useLocalDpi xmlns:a14="http://schemas.microsoft.com/office/drawing/2010/main" val="0"/>
+              </a:ext>
+            </a:extLst>
+          </a:blip>
+          <a:stretch>
+            <a:fillRect/>
+          </a:stretch>
+        </p:blipFill>
+        <p:spPr>
+          <a:xfrm>
+            <a:off x="2481943" y="1912775"/>
+            <a:ext cx="7016620" cy="3732245"/>
+          </a:xfrm>
+          <a:prstGeom prst="rect">
+            <a:avLst/>
+          </a:prstGeom>
+          <a:solidFill>
+            <a:srgbClr val="FFFFFF">
+              <a:shade val="85000"/>
+            </a:srgbClr>
+          </a:solidFill>
+          <a:ln w="88900" cap="sq">
+            <a:solidFill>
+              <a:srgbClr val="FFFFFF"/>
+            </a:solidFill>
+            <a:miter lim="800000"/>
+          </a:ln>
+          <a:effectLst>
+            <a:outerShdw blurRad="55000" dist="18000" dir="5400000" algn="tl" rotWithShape="0">
+              <a:srgbClr val="000000">
+                <a:alpha val="40000"/>
+              </a:srgbClr>
+            </a:outerShdw>
+          </a:effectLst>
+          <a:scene3d>
+            <a:camera prst="orthographicFront"/>
+            <a:lightRig rig="twoPt" dir="t">
+              <a:rot lat="0" lon="0" rev="7200000"/>
+            </a:lightRig>
+          </a:scene3d>
+          <a:sp3d>
+            <a:bevelT w="25400" h="19050"/>
+            <a:contourClr>
+              <a:srgbClr val="FFFFFF"/>
+            </a:contourClr>
+          </a:sp3d>
+        </p:spPr>
+      </p:pic>
+      <p:sp>
+        <p:nvSpPr>
+          <p:cNvPr id="7" name="TextBox 6">
+            <a:extLst>
+              <a:ext uri="{FF2B5EF4-FFF2-40B4-BE49-F238E27FC236}">
+                <a16:creationId xmlns:a16="http://schemas.microsoft.com/office/drawing/2014/main" id="{0ECD50B1-B906-6EDD-9569-AD889E2E6636}"/>
+              </a:ext>
+            </a:extLst>
+          </p:cNvPr>
+          <p:cNvSpPr txBox="1"/>
+          <p:nvPr/>
+        </p:nvSpPr>
+        <p:spPr>
+          <a:xfrm>
+            <a:off x="1730440" y="5818846"/>
+            <a:ext cx="9906879" cy="461665"/>
+          </a:xfrm>
+          <a:prstGeom prst="rect">
+            <a:avLst/>
+          </a:prstGeom>
+          <a:noFill/>
+        </p:spPr>
+        <p:txBody>
+          <a:bodyPr wrap="none" rtlCol="0">
+            <a:spAutoFit/>
+          </a:bodyPr>
+          <a:lstStyle/>
+          <a:p>
+            <a:pPr marL="171450" indent="-171450">
+              <a:buFont typeface="Arial" panose="020B0604020202020204" pitchFamily="34" charset="0"/>
+              <a:buChar char="•"/>
+            </a:pPr>
+            <a:r>
+              <a:rPr lang="en-IN" sz="1200" dirty="0">
+                <a:latin typeface="Roboto" panose="02000000000000000000" pitchFamily="2" charset="0"/>
+                <a:ea typeface="Roboto" panose="02000000000000000000" pitchFamily="2" charset="0"/>
+                <a:cs typeface="Roboto" panose="02000000000000000000" pitchFamily="2" charset="0"/>
+              </a:rPr>
+              <a:t>Random Forest achieves the highest Precision, F1 Score, and ROC-AUC, while matching the other models on Recall </a:t>
+            </a:r>
+          </a:p>
+          <a:p>
+            <a:pPr marL="171450" indent="-171450">
+              <a:buFont typeface="Arial" panose="020B0604020202020204" pitchFamily="34" charset="0"/>
+              <a:buChar char="•"/>
+            </a:pPr>
+            <a:r>
+              <a:rPr lang="en-IN" sz="1200" dirty="0">
+                <a:latin typeface="Roboto" panose="02000000000000000000" pitchFamily="2" charset="0"/>
+                <a:ea typeface="Roboto" panose="02000000000000000000" pitchFamily="2" charset="0"/>
+                <a:cs typeface="Roboto" panose="02000000000000000000" pitchFamily="2" charset="0"/>
+              </a:rPr>
+              <a:t>Logistic Regression's high Recall is misleading on its own — its much lower Precision means more false alarms for the same failures caught</a:t>
+            </a:r>
+          </a:p>
+        </p:txBody>
+      </p:sp>
     </p:spTree>
     <p:extLst>
       <p:ext uri="{BB962C8B-B14F-4D97-AF65-F5344CB8AC3E}">
-        <p14:creationId xmlns:p14="http://schemas.microsoft.com/office/powerpoint/2010/main" val="2220828657"/>
+        <p14:creationId xmlns:p14="http://schemas.microsoft.com/office/powerpoint/2010/main" val="980303277"/>
+      </p:ext>
+    </p:extLst>
+  </p:cSld>
+  <p:clrMapOvr>
+    <a:masterClrMapping/>
+  </p:clrMapOvr>
+</p:sld>
+</file>
+
+<file path=ppt/slides/slide7.xml><?xml version="1.0" encoding="utf-8"?>
+<p:sld xmlns:a="http://schemas.openxmlformats.org/drawingml/2006/main" xmlns:r="http://schemas.openxmlformats.org/officeDocument/2006/relationships" xmlns:p="http://schemas.openxmlformats.org/presentationml/2006/main">
+  <p:cSld>
+    <p:spTree>
+      <p:nvGrpSpPr>
+        <p:cNvPr id="1" name="Shape 349">
+          <a:extLst>
+            <a:ext uri="{FF2B5EF4-FFF2-40B4-BE49-F238E27FC236}">
+              <a16:creationId xmlns:a16="http://schemas.microsoft.com/office/drawing/2014/main" id="{7E8FA68A-9951-830C-0A61-BC1C563C1AF5}"/>
+            </a:ext>
+          </a:extLst>
+        </p:cNvPr>
+        <p:cNvGrpSpPr/>
+        <p:nvPr/>
+      </p:nvGrpSpPr>
+      <p:grpSpPr>
+        <a:xfrm>
+          <a:off x="0" y="0"/>
+          <a:ext cx="0" cy="0"/>
+          <a:chOff x="0" y="0"/>
+          <a:chExt cx="0" cy="0"/>
+        </a:xfrm>
+      </p:grpSpPr>
+      <p:sp>
+        <p:nvSpPr>
+          <p:cNvPr id="351" name="Google Shape;351;p15">
+            <a:extLst>
+              <a:ext uri="{FF2B5EF4-FFF2-40B4-BE49-F238E27FC236}">
+                <a16:creationId xmlns:a16="http://schemas.microsoft.com/office/drawing/2014/main" id="{613616E6-4518-74B7-3B16-D48DC9B68149}"/>
+              </a:ext>
+            </a:extLst>
+          </p:cNvPr>
+          <p:cNvSpPr txBox="1">
+            <a:spLocks noGrp="1"/>
+          </p:cNvSpPr>
+          <p:nvPr>
+            <p:ph type="ctrTitle"/>
+          </p:nvPr>
+        </p:nvSpPr>
+        <p:spPr>
+          <a:xfrm>
+            <a:off x="0" y="0"/>
+            <a:ext cx="12192000" cy="990211"/>
+          </a:xfrm>
+          <a:prstGeom prst="rect">
+            <a:avLst/>
+          </a:prstGeom>
+          <a:solidFill>
+            <a:srgbClr val="FF6A0E"/>
+          </a:solidFill>
+          <a:ln w="9525" cap="flat" cmpd="sng">
+            <a:solidFill>
+              <a:srgbClr val="FFFFFF"/>
+            </a:solidFill>
+            <a:prstDash val="solid"/>
+            <a:round/>
+            <a:headEnd type="none" w="sm" len="sm"/>
+            <a:tailEnd type="none" w="sm" len="sm"/>
+          </a:ln>
+        </p:spPr>
+        <p:txBody>
+          <a:bodyPr spcFirstLastPara="1" vert="horz" wrap="square" lIns="121900" tIns="121900" rIns="121900" bIns="121900" rtlCol="0" anchor="t" anchorCtr="0">
+            <a:noAutofit/>
+          </a:bodyPr>
+          <a:lstStyle/>
+          <a:p>
+            <a:pPr marL="599985">
+              <a:lnSpc>
+                <a:spcPct val="150000"/>
+              </a:lnSpc>
+              <a:spcBef>
+                <a:spcPts val="0"/>
+              </a:spcBef>
+              <a:spcAft>
+                <a:spcPts val="2133"/>
+              </a:spcAft>
+            </a:pPr>
+            <a:r>
+              <a:rPr lang="en-IN" sz="4000" b="1" dirty="0">
+                <a:solidFill>
+                  <a:schemeClr val="bg1"/>
+                </a:solidFill>
+                <a:latin typeface="Roboto" panose="02000000000000000000" pitchFamily="2" charset="0"/>
+                <a:ea typeface="Roboto" panose="02000000000000000000" pitchFamily="2" charset="0"/>
+                <a:cs typeface="Roboto" panose="02000000000000000000" pitchFamily="2" charset="0"/>
+              </a:rPr>
+              <a:t>CONFUSION MATRIX</a:t>
+            </a:r>
+            <a:endParaRPr lang="en-GB" sz="4000" b="1" dirty="0">
+              <a:solidFill>
+                <a:schemeClr val="bg1"/>
+              </a:solidFill>
+              <a:latin typeface="Roboto" panose="02000000000000000000" pitchFamily="2" charset="0"/>
+              <a:ea typeface="Roboto" panose="02000000000000000000" pitchFamily="2" charset="0"/>
+              <a:cs typeface="Roboto" panose="02000000000000000000" pitchFamily="2" charset="0"/>
+              <a:sym typeface="Roboto"/>
+            </a:endParaRPr>
+          </a:p>
+        </p:txBody>
+      </p:sp>
+      <p:sp>
+        <p:nvSpPr>
+          <p:cNvPr id="352" name="Google Shape;352;p15">
+            <a:extLst>
+              <a:ext uri="{FF2B5EF4-FFF2-40B4-BE49-F238E27FC236}">
+                <a16:creationId xmlns:a16="http://schemas.microsoft.com/office/drawing/2014/main" id="{717F9F82-B1CE-C33F-1B87-06C72AEAEA78}"/>
+              </a:ext>
+            </a:extLst>
+          </p:cNvPr>
+          <p:cNvSpPr txBox="1"/>
+          <p:nvPr/>
+        </p:nvSpPr>
+        <p:spPr>
+          <a:xfrm>
+            <a:off x="0" y="885534"/>
+            <a:ext cx="12192000" cy="5331200"/>
+          </a:xfrm>
+          <a:prstGeom prst="rect">
+            <a:avLst/>
+          </a:prstGeom>
+          <a:noFill/>
+          <a:ln>
+            <a:noFill/>
+          </a:ln>
+        </p:spPr>
+        <p:txBody>
+          <a:bodyPr spcFirstLastPara="1" wrap="square" lIns="365733" tIns="365733" rIns="365733" bIns="365733" anchor="t" anchorCtr="0">
+            <a:noAutofit/>
+          </a:bodyPr>
+          <a:lstStyle/>
+          <a:p>
+            <a:pPr algn="ctr">
+              <a:lnSpc>
+                <a:spcPct val="150000"/>
+              </a:lnSpc>
+            </a:pPr>
+            <a:r>
+              <a:rPr lang="en-IN" b="1" dirty="0">
+                <a:solidFill>
+                  <a:schemeClr val="accent2"/>
+                </a:solidFill>
+                <a:latin typeface="Roboto" panose="02000000000000000000" pitchFamily="2" charset="0"/>
+                <a:ea typeface="Roboto" panose="02000000000000000000" pitchFamily="2" charset="0"/>
+                <a:cs typeface="Roboto" panose="02000000000000000000" pitchFamily="2" charset="0"/>
+              </a:rPr>
+              <a:t>Confusion Matrix Comparison</a:t>
+            </a:r>
+            <a:endParaRPr b="1" dirty="0">
+              <a:solidFill>
+                <a:schemeClr val="accent2"/>
+              </a:solidFill>
+              <a:latin typeface="Roboto" panose="02000000000000000000" pitchFamily="2" charset="0"/>
+              <a:ea typeface="Roboto" panose="02000000000000000000" pitchFamily="2" charset="0"/>
+              <a:cs typeface="Roboto" panose="02000000000000000000" pitchFamily="2" charset="0"/>
+              <a:sym typeface="Roboto"/>
+            </a:endParaRPr>
+          </a:p>
+        </p:txBody>
+      </p:sp>
+      <p:sp>
+        <p:nvSpPr>
+          <p:cNvPr id="353" name="Google Shape;353;p15">
+            <a:extLst>
+              <a:ext uri="{FF2B5EF4-FFF2-40B4-BE49-F238E27FC236}">
+                <a16:creationId xmlns:a16="http://schemas.microsoft.com/office/drawing/2014/main" id="{A29331DE-AEF9-F2EA-E517-BA96B1B681D4}"/>
+              </a:ext>
+            </a:extLst>
+          </p:cNvPr>
+          <p:cNvSpPr txBox="1"/>
+          <p:nvPr/>
+        </p:nvSpPr>
+        <p:spPr>
+          <a:xfrm>
+            <a:off x="-13400" y="6400800"/>
+            <a:ext cx="12218800" cy="360800"/>
+          </a:xfrm>
+          <a:prstGeom prst="rect">
+            <a:avLst/>
+          </a:prstGeom>
+          <a:solidFill>
+            <a:srgbClr val="FF6A0E"/>
+          </a:solidFill>
+          <a:ln>
+            <a:noFill/>
+          </a:ln>
+        </p:spPr>
+        <p:txBody>
+          <a:bodyPr spcFirstLastPara="1" wrap="square" lIns="121900" tIns="121900" rIns="121900" bIns="121900" anchor="ctr" anchorCtr="0">
+            <a:noAutofit/>
+          </a:bodyPr>
+          <a:lstStyle/>
+          <a:p>
+            <a:pPr marR="243834" algn="r"/>
+            <a:r>
+              <a:rPr lang="en-GB" sz="1200" dirty="0">
+                <a:solidFill>
+                  <a:srgbClr val="FFFFFF"/>
+                </a:solidFill>
+                <a:latin typeface="Roboto"/>
+                <a:ea typeface="Roboto"/>
+                <a:cs typeface="Roboto"/>
+                <a:sym typeface="Roboto"/>
+              </a:rPr>
+              <a:t>© All rights reserved by </a:t>
+            </a:r>
+            <a:r>
+              <a:rPr lang="en-GB" sz="1200" dirty="0" err="1">
+                <a:solidFill>
+                  <a:srgbClr val="FFFFFF"/>
+                </a:solidFill>
+                <a:latin typeface="Roboto"/>
+                <a:ea typeface="Roboto"/>
+                <a:cs typeface="Roboto"/>
+                <a:sym typeface="Roboto"/>
+              </a:rPr>
+              <a:t>Fireblaze</a:t>
+            </a:r>
+            <a:r>
+              <a:rPr lang="en-GB" sz="1200" dirty="0">
+                <a:solidFill>
+                  <a:srgbClr val="FFFFFF"/>
+                </a:solidFill>
+                <a:latin typeface="Roboto"/>
+                <a:ea typeface="Roboto"/>
+                <a:cs typeface="Roboto"/>
+                <a:sym typeface="Roboto"/>
+              </a:rPr>
+              <a:t> Technologies </a:t>
+            </a:r>
+            <a:r>
+              <a:rPr lang="en-GB" sz="1200" dirty="0" err="1">
+                <a:solidFill>
+                  <a:srgbClr val="FFFFFF"/>
+                </a:solidFill>
+                <a:latin typeface="Roboto"/>
+                <a:ea typeface="Roboto"/>
+                <a:cs typeface="Roboto"/>
+                <a:sym typeface="Roboto"/>
+              </a:rPr>
+              <a:t>Pvt.</a:t>
+            </a:r>
+            <a:r>
+              <a:rPr lang="en-GB" sz="1200" dirty="0">
+                <a:solidFill>
+                  <a:srgbClr val="FFFFFF"/>
+                </a:solidFill>
+                <a:latin typeface="Roboto"/>
+                <a:ea typeface="Roboto"/>
+                <a:cs typeface="Roboto"/>
+                <a:sym typeface="Roboto"/>
+              </a:rPr>
+              <a:t> Ltd.</a:t>
+            </a:r>
+            <a:endParaRPr sz="1200" dirty="0">
+              <a:solidFill>
+                <a:srgbClr val="FFFFFF"/>
+              </a:solidFill>
+              <a:latin typeface="Roboto"/>
+              <a:ea typeface="Roboto"/>
+              <a:cs typeface="Roboto"/>
+              <a:sym typeface="Roboto"/>
+            </a:endParaRPr>
+          </a:p>
+        </p:txBody>
+      </p:sp>
+      <p:sp>
+        <p:nvSpPr>
+          <p:cNvPr id="354" name="Google Shape;354;p15">
+            <a:extLst>
+              <a:ext uri="{FF2B5EF4-FFF2-40B4-BE49-F238E27FC236}">
+                <a16:creationId xmlns:a16="http://schemas.microsoft.com/office/drawing/2014/main" id="{20C9055A-248C-7677-AB1D-9F92E69A839A}"/>
+              </a:ext>
+            </a:extLst>
+          </p:cNvPr>
+          <p:cNvSpPr/>
+          <p:nvPr/>
+        </p:nvSpPr>
+        <p:spPr>
+          <a:xfrm rot="10800000">
+            <a:off x="11516800" y="130333"/>
+            <a:ext cx="675200" cy="755200"/>
+          </a:xfrm>
+          <a:prstGeom prst="rtTriangle">
+            <a:avLst/>
+          </a:prstGeom>
+          <a:solidFill>
+            <a:srgbClr val="FF9900"/>
+          </a:solidFill>
+          <a:ln>
+            <a:noFill/>
+          </a:ln>
+        </p:spPr>
+        <p:txBody>
+          <a:bodyPr spcFirstLastPara="1" wrap="square" lIns="121900" tIns="121900" rIns="121900" bIns="121900" anchor="ctr" anchorCtr="0">
+            <a:noAutofit/>
+          </a:bodyPr>
+          <a:lstStyle/>
+          <a:p>
+            <a:endParaRPr sz="2400"/>
+          </a:p>
+        </p:txBody>
+      </p:sp>
+      <p:sp>
+        <p:nvSpPr>
+          <p:cNvPr id="355" name="Google Shape;355;p15">
+            <a:extLst>
+              <a:ext uri="{FF2B5EF4-FFF2-40B4-BE49-F238E27FC236}">
+                <a16:creationId xmlns:a16="http://schemas.microsoft.com/office/drawing/2014/main" id="{A344CA85-CE79-A133-7299-EE7936891BFA}"/>
+              </a:ext>
+            </a:extLst>
+          </p:cNvPr>
+          <p:cNvSpPr/>
+          <p:nvPr/>
+        </p:nvSpPr>
+        <p:spPr>
+          <a:xfrm>
+            <a:off x="0" y="6400800"/>
+            <a:ext cx="435200" cy="360800"/>
+          </a:xfrm>
+          <a:prstGeom prst="rtTriangle">
+            <a:avLst/>
+          </a:prstGeom>
+          <a:solidFill>
+            <a:srgbClr val="FF9900"/>
+          </a:solidFill>
+          <a:ln>
+            <a:noFill/>
+          </a:ln>
+        </p:spPr>
+        <p:txBody>
+          <a:bodyPr spcFirstLastPara="1" wrap="square" lIns="121900" tIns="121900" rIns="121900" bIns="121900" anchor="ctr" anchorCtr="0">
+            <a:noAutofit/>
+          </a:bodyPr>
+          <a:lstStyle/>
+          <a:p>
+            <a:endParaRPr sz="2400"/>
+          </a:p>
+        </p:txBody>
+      </p:sp>
+      <p:sp>
+        <p:nvSpPr>
+          <p:cNvPr id="4" name="TextBox 3">
+            <a:extLst>
+              <a:ext uri="{FF2B5EF4-FFF2-40B4-BE49-F238E27FC236}">
+                <a16:creationId xmlns:a16="http://schemas.microsoft.com/office/drawing/2014/main" id="{08D7E234-9C38-48C9-C852-CDCABB978010}"/>
+              </a:ext>
+            </a:extLst>
+          </p:cNvPr>
+          <p:cNvSpPr txBox="1"/>
+          <p:nvPr/>
+        </p:nvSpPr>
+        <p:spPr>
+          <a:xfrm>
+            <a:off x="2454704" y="5788400"/>
+            <a:ext cx="9062096" cy="461665"/>
+          </a:xfrm>
+          <a:prstGeom prst="rect">
+            <a:avLst/>
+          </a:prstGeom>
+          <a:noFill/>
+        </p:spPr>
+        <p:txBody>
+          <a:bodyPr wrap="none" rtlCol="0">
+            <a:spAutoFit/>
+          </a:bodyPr>
+          <a:lstStyle/>
+          <a:p>
+            <a:pPr marL="171450" indent="-171450">
+              <a:buFont typeface="Arial" panose="020B0604020202020204" pitchFamily="34" charset="0"/>
+              <a:buChar char="•"/>
+            </a:pPr>
+            <a:r>
+              <a:rPr lang="en-IN" sz="1200" dirty="0">
+                <a:latin typeface="Roboto" panose="02000000000000000000" pitchFamily="2" charset="0"/>
+                <a:ea typeface="Roboto" panose="02000000000000000000" pitchFamily="2" charset="0"/>
+                <a:cs typeface="Roboto" panose="02000000000000000000" pitchFamily="2" charset="0"/>
+              </a:rPr>
+              <a:t>Random Forest correctly caught 56 of 68 actual failures, missing only 12 — a Recall of ~82% </a:t>
+            </a:r>
+          </a:p>
+          <a:p>
+            <a:pPr marL="171450" indent="-171450">
+              <a:buFont typeface="Arial" panose="020B0604020202020204" pitchFamily="34" charset="0"/>
+              <a:buChar char="•"/>
+            </a:pPr>
+            <a:r>
+              <a:rPr lang="en-IN" sz="1200" dirty="0">
+                <a:latin typeface="Roboto" panose="02000000000000000000" pitchFamily="2" charset="0"/>
+                <a:ea typeface="Roboto" panose="02000000000000000000" pitchFamily="2" charset="0"/>
+                <a:cs typeface="Roboto" panose="02000000000000000000" pitchFamily="2" charset="0"/>
+              </a:rPr>
+              <a:t>It accepted 85 false alarms in exchange, a reasonable </a:t>
+            </a:r>
+            <a:r>
+              <a:rPr lang="en-IN" sz="1200" dirty="0" err="1">
+                <a:latin typeface="Roboto" panose="02000000000000000000" pitchFamily="2" charset="0"/>
+                <a:ea typeface="Roboto" panose="02000000000000000000" pitchFamily="2" charset="0"/>
+                <a:cs typeface="Roboto" panose="02000000000000000000" pitchFamily="2" charset="0"/>
+              </a:rPr>
+              <a:t>tradeoff</a:t>
+            </a:r>
+            <a:r>
+              <a:rPr lang="en-IN" sz="1200" dirty="0">
+                <a:latin typeface="Roboto" panose="02000000000000000000" pitchFamily="2" charset="0"/>
+                <a:ea typeface="Roboto" panose="02000000000000000000" pitchFamily="2" charset="0"/>
+                <a:cs typeface="Roboto" panose="02000000000000000000" pitchFamily="2" charset="0"/>
+              </a:rPr>
+              <a:t> since missed failures are costlier than unnecessary inspections</a:t>
+            </a:r>
+          </a:p>
+        </p:txBody>
+      </p:sp>
+      <p:pic>
+        <p:nvPicPr>
+          <p:cNvPr id="5" name="Picture 4">
+            <a:extLst>
+              <a:ext uri="{FF2B5EF4-FFF2-40B4-BE49-F238E27FC236}">
+                <a16:creationId xmlns:a16="http://schemas.microsoft.com/office/drawing/2014/main" id="{B6F40B14-F1CD-1983-F3BA-1C6BBB8B8777}"/>
+              </a:ext>
+            </a:extLst>
+          </p:cNvPr>
+          <p:cNvPicPr>
+            <a:picLocks noChangeAspect="1"/>
+          </p:cNvPicPr>
+          <p:nvPr/>
+        </p:nvPicPr>
+        <p:blipFill>
+          <a:blip r:embed="rId3">
+            <a:extLst>
+              <a:ext uri="{28A0092B-C50C-407E-A947-70E740481C1C}">
+                <a14:useLocalDpi xmlns:a14="http://schemas.microsoft.com/office/drawing/2010/main" val="0"/>
+              </a:ext>
+            </a:extLst>
+          </a:blip>
+          <a:stretch>
+            <a:fillRect/>
+          </a:stretch>
+        </p:blipFill>
+        <p:spPr>
+          <a:xfrm>
+            <a:off x="8253343" y="2097336"/>
+            <a:ext cx="3653584" cy="3230444"/>
+          </a:xfrm>
+          <a:prstGeom prst="rect">
+            <a:avLst/>
+          </a:prstGeom>
+          <a:solidFill>
+            <a:srgbClr val="FFFFFF">
+              <a:shade val="85000"/>
+            </a:srgbClr>
+          </a:solidFill>
+          <a:ln w="88900" cap="sq">
+            <a:solidFill>
+              <a:srgbClr val="FFFFFF"/>
+            </a:solidFill>
+            <a:miter lim="800000"/>
+          </a:ln>
+          <a:effectLst>
+            <a:outerShdw blurRad="55000" dist="18000" dir="5400000" algn="tl" rotWithShape="0">
+              <a:srgbClr val="000000">
+                <a:alpha val="40000"/>
+              </a:srgbClr>
+            </a:outerShdw>
+          </a:effectLst>
+          <a:scene3d>
+            <a:camera prst="orthographicFront"/>
+            <a:lightRig rig="twoPt" dir="t">
+              <a:rot lat="0" lon="0" rev="7200000"/>
+            </a:lightRig>
+          </a:scene3d>
+          <a:sp3d>
+            <a:bevelT w="25400" h="19050"/>
+            <a:contourClr>
+              <a:srgbClr val="FFFFFF"/>
+            </a:contourClr>
+          </a:sp3d>
+        </p:spPr>
+      </p:pic>
+      <p:pic>
+        <p:nvPicPr>
+          <p:cNvPr id="3" name="Picture 2">
+            <a:extLst>
+              <a:ext uri="{FF2B5EF4-FFF2-40B4-BE49-F238E27FC236}">
+                <a16:creationId xmlns:a16="http://schemas.microsoft.com/office/drawing/2014/main" id="{D31AD24A-4149-CD13-DC0D-992EB7DFC426}"/>
+              </a:ext>
+            </a:extLst>
+          </p:cNvPr>
+          <p:cNvPicPr>
+            <a:picLocks noChangeAspect="1"/>
+          </p:cNvPicPr>
+          <p:nvPr/>
+        </p:nvPicPr>
+        <p:blipFill>
+          <a:blip r:embed="rId4">
+            <a:extLst>
+              <a:ext uri="{28A0092B-C50C-407E-A947-70E740481C1C}">
+                <a14:useLocalDpi xmlns:a14="http://schemas.microsoft.com/office/drawing/2010/main" val="0"/>
+              </a:ext>
+            </a:extLst>
+          </a:blip>
+          <a:stretch>
+            <a:fillRect/>
+          </a:stretch>
+        </p:blipFill>
+        <p:spPr>
+          <a:xfrm>
+            <a:off x="217600" y="2097335"/>
+            <a:ext cx="3721059" cy="3230444"/>
+          </a:xfrm>
+          <a:prstGeom prst="rect">
+            <a:avLst/>
+          </a:prstGeom>
+          <a:solidFill>
+            <a:srgbClr val="FFFFFF">
+              <a:shade val="85000"/>
+            </a:srgbClr>
+          </a:solidFill>
+          <a:ln w="88900" cap="sq">
+            <a:solidFill>
+              <a:srgbClr val="FFFFFF"/>
+            </a:solidFill>
+            <a:miter lim="800000"/>
+          </a:ln>
+          <a:effectLst>
+            <a:outerShdw blurRad="55000" dist="18000" dir="5400000" algn="tl" rotWithShape="0">
+              <a:srgbClr val="000000">
+                <a:alpha val="40000"/>
+              </a:srgbClr>
+            </a:outerShdw>
+          </a:effectLst>
+          <a:scene3d>
+            <a:camera prst="orthographicFront"/>
+            <a:lightRig rig="twoPt" dir="t">
+              <a:rot lat="0" lon="0" rev="7200000"/>
+            </a:lightRig>
+          </a:scene3d>
+          <a:sp3d>
+            <a:bevelT w="25400" h="19050"/>
+            <a:contourClr>
+              <a:srgbClr val="FFFFFF"/>
+            </a:contourClr>
+          </a:sp3d>
+        </p:spPr>
+      </p:pic>
+      <p:pic>
+        <p:nvPicPr>
+          <p:cNvPr id="7" name="Picture 6">
+            <a:extLst>
+              <a:ext uri="{FF2B5EF4-FFF2-40B4-BE49-F238E27FC236}">
+                <a16:creationId xmlns:a16="http://schemas.microsoft.com/office/drawing/2014/main" id="{7D489E2C-8E03-1D18-C6A2-C62F79F5AEA9}"/>
+              </a:ext>
+            </a:extLst>
+          </p:cNvPr>
+          <p:cNvPicPr>
+            <a:picLocks noChangeAspect="1"/>
+          </p:cNvPicPr>
+          <p:nvPr/>
+        </p:nvPicPr>
+        <p:blipFill>
+          <a:blip r:embed="rId5">
+            <a:extLst>
+              <a:ext uri="{28A0092B-C50C-407E-A947-70E740481C1C}">
+                <a14:useLocalDpi xmlns:a14="http://schemas.microsoft.com/office/drawing/2010/main" val="0"/>
+              </a:ext>
+            </a:extLst>
+          </a:blip>
+          <a:stretch>
+            <a:fillRect/>
+          </a:stretch>
+        </p:blipFill>
+        <p:spPr>
+          <a:xfrm>
+            <a:off x="4414744" y="2097336"/>
+            <a:ext cx="3362514" cy="3230444"/>
+          </a:xfrm>
+          <a:prstGeom prst="rect">
+            <a:avLst/>
+          </a:prstGeom>
+          <a:solidFill>
+            <a:srgbClr val="FFFFFF">
+              <a:shade val="85000"/>
+            </a:srgbClr>
+          </a:solidFill>
+          <a:ln w="88900" cap="sq">
+            <a:solidFill>
+              <a:srgbClr val="FFFFFF"/>
+            </a:solidFill>
+            <a:miter lim="800000"/>
+          </a:ln>
+          <a:effectLst>
+            <a:outerShdw blurRad="55000" dist="18000" dir="5400000" algn="tl" rotWithShape="0">
+              <a:srgbClr val="000000">
+                <a:alpha val="40000"/>
+              </a:srgbClr>
+            </a:outerShdw>
+          </a:effectLst>
+          <a:scene3d>
+            <a:camera prst="orthographicFront"/>
+            <a:lightRig rig="twoPt" dir="t">
+              <a:rot lat="0" lon="0" rev="7200000"/>
+            </a:lightRig>
+          </a:scene3d>
+          <a:sp3d>
+            <a:bevelT w="25400" h="19050"/>
+            <a:contourClr>
+              <a:srgbClr val="FFFFFF"/>
+            </a:contourClr>
+          </a:sp3d>
+        </p:spPr>
+      </p:pic>
+    </p:spTree>
+    <p:extLst>
+      <p:ext uri="{BB962C8B-B14F-4D97-AF65-F5344CB8AC3E}">
+        <p14:creationId xmlns:p14="http://schemas.microsoft.com/office/powerpoint/2010/main" val="1637995572"/>
+      </p:ext>
+    </p:extLst>
+  </p:cSld>
+  <p:clrMapOvr>
+    <a:masterClrMapping/>
+  </p:clrMapOvr>
+</p:sld>
+</file>
+
+<file path=ppt/slides/slide8.xml><?xml version="1.0" encoding="utf-8"?>
+<p:sld xmlns:a="http://schemas.openxmlformats.org/drawingml/2006/main" xmlns:r="http://schemas.openxmlformats.org/officeDocument/2006/relationships" xmlns:p="http://schemas.openxmlformats.org/presentationml/2006/main">
+  <p:cSld>
+    <p:spTree>
+      <p:nvGrpSpPr>
+        <p:cNvPr id="1" name="Shape 349">
+          <a:extLst>
+            <a:ext uri="{FF2B5EF4-FFF2-40B4-BE49-F238E27FC236}">
+              <a16:creationId xmlns:a16="http://schemas.microsoft.com/office/drawing/2014/main" id="{7C918EF3-885D-2D8C-FD12-73DFE3A14E07}"/>
+            </a:ext>
+          </a:extLst>
+        </p:cNvPr>
+        <p:cNvGrpSpPr/>
+        <p:nvPr/>
+      </p:nvGrpSpPr>
+      <p:grpSpPr>
+        <a:xfrm>
+          <a:off x="0" y="0"/>
+          <a:ext cx="0" cy="0"/>
+          <a:chOff x="0" y="0"/>
+          <a:chExt cx="0" cy="0"/>
+        </a:xfrm>
+      </p:grpSpPr>
+      <p:sp>
+        <p:nvSpPr>
+          <p:cNvPr id="351" name="Google Shape;351;p15">
+            <a:extLst>
+              <a:ext uri="{FF2B5EF4-FFF2-40B4-BE49-F238E27FC236}">
+                <a16:creationId xmlns:a16="http://schemas.microsoft.com/office/drawing/2014/main" id="{90648E8B-FF2B-D9AA-C544-54EB6F9C0FBD}"/>
+              </a:ext>
+            </a:extLst>
+          </p:cNvPr>
+          <p:cNvSpPr txBox="1">
+            <a:spLocks noGrp="1"/>
+          </p:cNvSpPr>
+          <p:nvPr>
+            <p:ph type="ctrTitle"/>
+          </p:nvPr>
+        </p:nvSpPr>
+        <p:spPr>
+          <a:xfrm>
+            <a:off x="0" y="0"/>
+            <a:ext cx="12192000" cy="990211"/>
+          </a:xfrm>
+          <a:prstGeom prst="rect">
+            <a:avLst/>
+          </a:prstGeom>
+          <a:solidFill>
+            <a:srgbClr val="FF6A0E"/>
+          </a:solidFill>
+          <a:ln w="9525" cap="flat" cmpd="sng">
+            <a:solidFill>
+              <a:srgbClr val="FFFFFF"/>
+            </a:solidFill>
+            <a:prstDash val="solid"/>
+            <a:round/>
+            <a:headEnd type="none" w="sm" len="sm"/>
+            <a:tailEnd type="none" w="sm" len="sm"/>
+          </a:ln>
+        </p:spPr>
+        <p:txBody>
+          <a:bodyPr spcFirstLastPara="1" vert="horz" wrap="square" lIns="121900" tIns="121900" rIns="121900" bIns="121900" rtlCol="0" anchor="t" anchorCtr="0">
+            <a:noAutofit/>
+          </a:bodyPr>
+          <a:lstStyle/>
+          <a:p>
+            <a:pPr marL="599985">
+              <a:lnSpc>
+                <a:spcPct val="150000"/>
+              </a:lnSpc>
+              <a:spcBef>
+                <a:spcPts val="0"/>
+              </a:spcBef>
+              <a:spcAft>
+                <a:spcPts val="2133"/>
+              </a:spcAft>
+            </a:pPr>
+            <a:r>
+              <a:rPr lang="en-GB" sz="4000" b="1" dirty="0">
+                <a:solidFill>
+                  <a:srgbClr val="FFFFFF"/>
+                </a:solidFill>
+                <a:latin typeface="Roboto"/>
+                <a:ea typeface="Roboto"/>
+                <a:cs typeface="Roboto"/>
+                <a:sym typeface="Roboto"/>
+              </a:rPr>
+              <a:t>PROPOSED SOLUTION</a:t>
+            </a:r>
+          </a:p>
+        </p:txBody>
+      </p:sp>
+      <p:sp>
+        <p:nvSpPr>
+          <p:cNvPr id="352" name="Google Shape;352;p15">
+            <a:extLst>
+              <a:ext uri="{FF2B5EF4-FFF2-40B4-BE49-F238E27FC236}">
+                <a16:creationId xmlns:a16="http://schemas.microsoft.com/office/drawing/2014/main" id="{3D06DF0C-2A7C-F549-ABC8-2874D80724ED}"/>
+              </a:ext>
+            </a:extLst>
+          </p:cNvPr>
+          <p:cNvSpPr txBox="1"/>
+          <p:nvPr/>
+        </p:nvSpPr>
+        <p:spPr>
+          <a:xfrm>
+            <a:off x="0" y="1069600"/>
+            <a:ext cx="12192000" cy="5331200"/>
+          </a:xfrm>
+          <a:prstGeom prst="rect">
+            <a:avLst/>
+          </a:prstGeom>
+          <a:noFill/>
+          <a:ln>
+            <a:noFill/>
+          </a:ln>
+        </p:spPr>
+        <p:txBody>
+          <a:bodyPr spcFirstLastPara="1" wrap="square" lIns="365733" tIns="365733" rIns="365733" bIns="365733" anchor="t" anchorCtr="0">
+            <a:noAutofit/>
+          </a:bodyPr>
+          <a:lstStyle/>
+          <a:p>
+            <a:pPr marL="285750" indent="-285750">
+              <a:lnSpc>
+                <a:spcPct val="150000"/>
+              </a:lnSpc>
+              <a:buFont typeface="Arial" panose="020B0604020202020204" pitchFamily="34" charset="0"/>
+              <a:buChar char="•"/>
+            </a:pPr>
+            <a:r>
+              <a:rPr lang="en-IN" sz="1600" dirty="0">
+                <a:latin typeface="Roboto" panose="02000000000000000000" pitchFamily="2" charset="0"/>
+                <a:ea typeface="Roboto" panose="02000000000000000000" pitchFamily="2" charset="0"/>
+                <a:cs typeface="Roboto" panose="02000000000000000000" pitchFamily="2" charset="0"/>
+              </a:rPr>
+              <a:t>A </a:t>
+            </a:r>
+            <a:r>
+              <a:rPr lang="en-IN" sz="1600" b="1" dirty="0">
+                <a:solidFill>
+                  <a:schemeClr val="accent2"/>
+                </a:solidFill>
+                <a:latin typeface="Roboto" panose="02000000000000000000" pitchFamily="2" charset="0"/>
+                <a:ea typeface="Roboto" panose="02000000000000000000" pitchFamily="2" charset="0"/>
+                <a:cs typeface="Roboto" panose="02000000000000000000" pitchFamily="2" charset="0"/>
+              </a:rPr>
+              <a:t>two-stage supervised ML pipeline</a:t>
+            </a:r>
+            <a:r>
+              <a:rPr lang="en-IN" sz="1600" dirty="0">
+                <a:solidFill>
+                  <a:schemeClr val="accent2"/>
+                </a:solidFill>
+                <a:latin typeface="Roboto" panose="02000000000000000000" pitchFamily="2" charset="0"/>
+                <a:ea typeface="Roboto" panose="02000000000000000000" pitchFamily="2" charset="0"/>
+                <a:cs typeface="Roboto" panose="02000000000000000000" pitchFamily="2" charset="0"/>
+              </a:rPr>
+              <a:t>,</a:t>
+            </a:r>
+            <a:r>
+              <a:rPr lang="en-IN" sz="1600" dirty="0">
+                <a:latin typeface="Roboto" panose="02000000000000000000" pitchFamily="2" charset="0"/>
+                <a:ea typeface="Roboto" panose="02000000000000000000" pitchFamily="2" charset="0"/>
+                <a:cs typeface="Roboto" panose="02000000000000000000" pitchFamily="2" charset="0"/>
+              </a:rPr>
+              <a:t> mirroring how predictive maintenance would actually be deployed: </a:t>
+            </a:r>
+          </a:p>
+          <a:p>
+            <a:pPr>
+              <a:lnSpc>
+                <a:spcPct val="150000"/>
+              </a:lnSpc>
+            </a:pPr>
+            <a:r>
+              <a:rPr lang="en-IN" sz="1600" b="1" dirty="0">
+                <a:latin typeface="Roboto" panose="02000000000000000000" pitchFamily="2" charset="0"/>
+                <a:ea typeface="Roboto" panose="02000000000000000000" pitchFamily="2" charset="0"/>
+                <a:cs typeface="Roboto" panose="02000000000000000000" pitchFamily="2" charset="0"/>
+              </a:rPr>
+              <a:t>      </a:t>
+            </a:r>
+            <a:r>
+              <a:rPr lang="en-IN" sz="1600" b="1" dirty="0">
+                <a:solidFill>
+                  <a:schemeClr val="accent2"/>
+                </a:solidFill>
+                <a:latin typeface="Roboto" panose="02000000000000000000" pitchFamily="2" charset="0"/>
+                <a:ea typeface="Roboto" panose="02000000000000000000" pitchFamily="2" charset="0"/>
+                <a:cs typeface="Roboto" panose="02000000000000000000" pitchFamily="2" charset="0"/>
+              </a:rPr>
+              <a:t>Stage 1:  Failure Detection (Binary Classification):</a:t>
+            </a:r>
+            <a:r>
+              <a:rPr lang="en-IN" sz="1600" dirty="0">
+                <a:solidFill>
+                  <a:schemeClr val="accent2"/>
+                </a:solidFill>
+                <a:latin typeface="Roboto" panose="02000000000000000000" pitchFamily="2" charset="0"/>
+                <a:ea typeface="Roboto" panose="02000000000000000000" pitchFamily="2" charset="0"/>
+                <a:cs typeface="Roboto" panose="02000000000000000000" pitchFamily="2" charset="0"/>
+              </a:rPr>
+              <a:t> </a:t>
+            </a:r>
+            <a:r>
+              <a:rPr lang="en-IN" sz="1600" dirty="0">
+                <a:latin typeface="Roboto" panose="02000000000000000000" pitchFamily="2" charset="0"/>
+                <a:ea typeface="Roboto" panose="02000000000000000000" pitchFamily="2" charset="0"/>
+                <a:cs typeface="Roboto" panose="02000000000000000000" pitchFamily="2" charset="0"/>
+              </a:rPr>
+              <a:t>Predicts whether a machine will fail, using Logistic Regression, Decision Tree, and           Random Forest, compared head-to-head.</a:t>
+            </a:r>
+          </a:p>
+          <a:p>
+            <a:pPr>
+              <a:lnSpc>
+                <a:spcPct val="150000"/>
+              </a:lnSpc>
+            </a:pPr>
+            <a:r>
+              <a:rPr lang="en-IN" sz="1600" b="1" dirty="0">
+                <a:latin typeface="Roboto" panose="02000000000000000000" pitchFamily="2" charset="0"/>
+                <a:ea typeface="Roboto" panose="02000000000000000000" pitchFamily="2" charset="0"/>
+                <a:cs typeface="Roboto" panose="02000000000000000000" pitchFamily="2" charset="0"/>
+              </a:rPr>
+              <a:t>      </a:t>
+            </a:r>
+            <a:r>
+              <a:rPr lang="en-IN" sz="1600" b="1" dirty="0">
+                <a:solidFill>
+                  <a:schemeClr val="accent2"/>
+                </a:solidFill>
+                <a:latin typeface="Roboto" panose="02000000000000000000" pitchFamily="2" charset="0"/>
+                <a:ea typeface="Roboto" panose="02000000000000000000" pitchFamily="2" charset="0"/>
+                <a:cs typeface="Roboto" panose="02000000000000000000" pitchFamily="2" charset="0"/>
+              </a:rPr>
+              <a:t>Stage 2: Failure Diagnosis (Multiclass Classification):</a:t>
+            </a:r>
+            <a:r>
+              <a:rPr lang="en-IN" sz="1600" dirty="0">
+                <a:latin typeface="Roboto" panose="02000000000000000000" pitchFamily="2" charset="0"/>
+                <a:ea typeface="Roboto" panose="02000000000000000000" pitchFamily="2" charset="0"/>
+                <a:cs typeface="Roboto" panose="02000000000000000000" pitchFamily="2" charset="0"/>
+              </a:rPr>
+              <a:t> For machines flagged as failing, a Random Forest model identifies the most likely failure type.</a:t>
+            </a:r>
+          </a:p>
+          <a:p>
+            <a:pPr marL="285750" indent="-285750">
+              <a:lnSpc>
+                <a:spcPct val="150000"/>
+              </a:lnSpc>
+              <a:buFont typeface="Arial" panose="020B0604020202020204" pitchFamily="34" charset="0"/>
+              <a:buChar char="•"/>
+            </a:pPr>
+            <a:r>
+              <a:rPr lang="en-IN" sz="1600" b="1" dirty="0">
+                <a:solidFill>
+                  <a:schemeClr val="accent2"/>
+                </a:solidFill>
+                <a:latin typeface="Roboto" panose="02000000000000000000" pitchFamily="2" charset="0"/>
+                <a:ea typeface="Roboto" panose="02000000000000000000" pitchFamily="2" charset="0"/>
+                <a:cs typeface="Roboto" panose="02000000000000000000" pitchFamily="2" charset="0"/>
+              </a:rPr>
+              <a:t>Handling the imbalance:</a:t>
+            </a:r>
+            <a:r>
+              <a:rPr lang="en-IN" sz="1600" dirty="0">
+                <a:solidFill>
+                  <a:schemeClr val="accent2"/>
+                </a:solidFill>
+                <a:latin typeface="Roboto" panose="02000000000000000000" pitchFamily="2" charset="0"/>
+                <a:ea typeface="Roboto" panose="02000000000000000000" pitchFamily="2" charset="0"/>
+                <a:cs typeface="Roboto" panose="02000000000000000000" pitchFamily="2" charset="0"/>
+              </a:rPr>
+              <a:t> </a:t>
+            </a:r>
+            <a:r>
+              <a:rPr lang="en-IN" sz="1600" dirty="0">
+                <a:latin typeface="Roboto" panose="02000000000000000000" pitchFamily="2" charset="0"/>
+                <a:ea typeface="Roboto" panose="02000000000000000000" pitchFamily="2" charset="0"/>
+                <a:cs typeface="Roboto" panose="02000000000000000000" pitchFamily="2" charset="0"/>
+              </a:rPr>
+              <a:t>SMOTE (Synthetic Minority Oversampling) applied only to training data, never to test data, to avoid data leakage.</a:t>
+            </a:r>
+          </a:p>
+          <a:p>
+            <a:pPr marL="285750" indent="-285750">
+              <a:lnSpc>
+                <a:spcPct val="150000"/>
+              </a:lnSpc>
+              <a:buFont typeface="Arial" panose="020B0604020202020204" pitchFamily="34" charset="0"/>
+              <a:buChar char="•"/>
+            </a:pPr>
+            <a:r>
+              <a:rPr lang="en-IN" sz="1600" b="1" dirty="0">
+                <a:solidFill>
+                  <a:schemeClr val="accent2"/>
+                </a:solidFill>
+                <a:latin typeface="Roboto" panose="02000000000000000000" pitchFamily="2" charset="0"/>
+                <a:ea typeface="Roboto" panose="02000000000000000000" pitchFamily="2" charset="0"/>
+                <a:cs typeface="Roboto" panose="02000000000000000000" pitchFamily="2" charset="0"/>
+              </a:rPr>
+              <a:t>Evaluation metrics:</a:t>
+            </a:r>
+            <a:r>
+              <a:rPr lang="en-IN" sz="1600" dirty="0">
+                <a:solidFill>
+                  <a:schemeClr val="accent2"/>
+                </a:solidFill>
+                <a:latin typeface="Roboto" panose="02000000000000000000" pitchFamily="2" charset="0"/>
+                <a:ea typeface="Roboto" panose="02000000000000000000" pitchFamily="2" charset="0"/>
+                <a:cs typeface="Roboto" panose="02000000000000000000" pitchFamily="2" charset="0"/>
+              </a:rPr>
+              <a:t> </a:t>
+            </a:r>
+            <a:r>
+              <a:rPr lang="en-IN" sz="1600" dirty="0">
+                <a:latin typeface="Roboto" panose="02000000000000000000" pitchFamily="2" charset="0"/>
+                <a:ea typeface="Roboto" panose="02000000000000000000" pitchFamily="2" charset="0"/>
+                <a:cs typeface="Roboto" panose="02000000000000000000" pitchFamily="2" charset="0"/>
+              </a:rPr>
+              <a:t>Precision, Recall, F1-score, ROC-AUC — not plain accuracy, since accuracy is misleading on this dataset. </a:t>
+            </a:r>
+          </a:p>
+          <a:p>
+            <a:pPr marL="285750" indent="-285750">
+              <a:lnSpc>
+                <a:spcPct val="150000"/>
+              </a:lnSpc>
+              <a:buFont typeface="Arial" panose="020B0604020202020204" pitchFamily="34" charset="0"/>
+              <a:buChar char="•"/>
+            </a:pPr>
+            <a:r>
+              <a:rPr lang="en-IN" sz="1600" b="1" dirty="0">
+                <a:solidFill>
+                  <a:schemeClr val="accent2"/>
+                </a:solidFill>
+                <a:latin typeface="Roboto" panose="02000000000000000000" pitchFamily="2" charset="0"/>
+                <a:ea typeface="Roboto" panose="02000000000000000000" pitchFamily="2" charset="0"/>
+                <a:cs typeface="Roboto" panose="02000000000000000000" pitchFamily="2" charset="0"/>
+              </a:rPr>
+              <a:t>Why Recall matters most here:</a:t>
+            </a:r>
+            <a:r>
+              <a:rPr lang="en-IN" sz="1600" dirty="0">
+                <a:latin typeface="Roboto" panose="02000000000000000000" pitchFamily="2" charset="0"/>
+                <a:ea typeface="Roboto" panose="02000000000000000000" pitchFamily="2" charset="0"/>
+                <a:cs typeface="Roboto" panose="02000000000000000000" pitchFamily="2" charset="0"/>
+              </a:rPr>
+              <a:t> missing a real failure (false negative) is far costlier than a false alarm (false positive) in a maintenance context.</a:t>
+            </a:r>
+          </a:p>
+          <a:p>
+            <a:pPr marL="285750" indent="-285750">
+              <a:lnSpc>
+                <a:spcPct val="150000"/>
+              </a:lnSpc>
+              <a:buFont typeface="Arial" panose="020B0604020202020204" pitchFamily="34" charset="0"/>
+              <a:buChar char="•"/>
+            </a:pPr>
+            <a:r>
+              <a:rPr lang="en-IN" sz="1600" b="1" dirty="0">
+                <a:solidFill>
+                  <a:schemeClr val="accent2"/>
+                </a:solidFill>
+                <a:latin typeface="Roboto" panose="02000000000000000000" pitchFamily="2" charset="0"/>
+                <a:ea typeface="Roboto" panose="02000000000000000000" pitchFamily="2" charset="0"/>
+                <a:cs typeface="Roboto" panose="02000000000000000000" pitchFamily="2" charset="0"/>
+              </a:rPr>
+              <a:t>Final model chosen:</a:t>
+            </a:r>
+            <a:r>
+              <a:rPr lang="en-IN" sz="1600" dirty="0">
+                <a:solidFill>
+                  <a:schemeClr val="accent2"/>
+                </a:solidFill>
+                <a:latin typeface="Roboto" panose="02000000000000000000" pitchFamily="2" charset="0"/>
+                <a:ea typeface="Roboto" panose="02000000000000000000" pitchFamily="2" charset="0"/>
+                <a:cs typeface="Roboto" panose="02000000000000000000" pitchFamily="2" charset="0"/>
+              </a:rPr>
+              <a:t> </a:t>
+            </a:r>
+            <a:r>
+              <a:rPr lang="en-IN" sz="1600" dirty="0">
+                <a:latin typeface="Roboto" panose="02000000000000000000" pitchFamily="2" charset="0"/>
+                <a:ea typeface="Roboto" panose="02000000000000000000" pitchFamily="2" charset="0"/>
+                <a:cs typeface="Roboto" panose="02000000000000000000" pitchFamily="2" charset="0"/>
+              </a:rPr>
+              <a:t>Random Forest — best balance of Recall and F1 across the test results.</a:t>
+            </a:r>
+            <a:endParaRPr sz="1600" dirty="0">
+              <a:solidFill>
+                <a:schemeClr val="dk1"/>
+              </a:solidFill>
+              <a:latin typeface="Roboto" panose="02000000000000000000" pitchFamily="2" charset="0"/>
+              <a:ea typeface="Roboto" panose="02000000000000000000" pitchFamily="2" charset="0"/>
+              <a:cs typeface="Roboto" panose="02000000000000000000" pitchFamily="2" charset="0"/>
+              <a:sym typeface="Roboto"/>
+            </a:endParaRPr>
+          </a:p>
+        </p:txBody>
+      </p:sp>
+      <p:sp>
+        <p:nvSpPr>
+          <p:cNvPr id="353" name="Google Shape;353;p15">
+            <a:extLst>
+              <a:ext uri="{FF2B5EF4-FFF2-40B4-BE49-F238E27FC236}">
+                <a16:creationId xmlns:a16="http://schemas.microsoft.com/office/drawing/2014/main" id="{86208C7C-3220-C0AE-BCBA-E35892E311A8}"/>
+              </a:ext>
+            </a:extLst>
+          </p:cNvPr>
+          <p:cNvSpPr txBox="1"/>
+          <p:nvPr/>
+        </p:nvSpPr>
+        <p:spPr>
+          <a:xfrm>
+            <a:off x="-13400" y="6400800"/>
+            <a:ext cx="12218800" cy="360800"/>
+          </a:xfrm>
+          <a:prstGeom prst="rect">
+            <a:avLst/>
+          </a:prstGeom>
+          <a:solidFill>
+            <a:srgbClr val="FF6A0E"/>
+          </a:solidFill>
+          <a:ln>
+            <a:noFill/>
+          </a:ln>
+        </p:spPr>
+        <p:txBody>
+          <a:bodyPr spcFirstLastPara="1" wrap="square" lIns="121900" tIns="121900" rIns="121900" bIns="121900" anchor="ctr" anchorCtr="0">
+            <a:noAutofit/>
+          </a:bodyPr>
+          <a:lstStyle/>
+          <a:p>
+            <a:pPr marR="243834" algn="r"/>
+            <a:r>
+              <a:rPr lang="en-GB" sz="1200" dirty="0">
+                <a:solidFill>
+                  <a:srgbClr val="FFFFFF"/>
+                </a:solidFill>
+                <a:latin typeface="Roboto"/>
+                <a:ea typeface="Roboto"/>
+                <a:cs typeface="Roboto"/>
+                <a:sym typeface="Roboto"/>
+              </a:rPr>
+              <a:t>© All rights reserved by </a:t>
+            </a:r>
+            <a:r>
+              <a:rPr lang="en-GB" sz="1200" dirty="0" err="1">
+                <a:solidFill>
+                  <a:srgbClr val="FFFFFF"/>
+                </a:solidFill>
+                <a:latin typeface="Roboto"/>
+                <a:ea typeface="Roboto"/>
+                <a:cs typeface="Roboto"/>
+                <a:sym typeface="Roboto"/>
+              </a:rPr>
+              <a:t>Fireblaze</a:t>
+            </a:r>
+            <a:r>
+              <a:rPr lang="en-GB" sz="1200" dirty="0">
+                <a:solidFill>
+                  <a:srgbClr val="FFFFFF"/>
+                </a:solidFill>
+                <a:latin typeface="Roboto"/>
+                <a:ea typeface="Roboto"/>
+                <a:cs typeface="Roboto"/>
+                <a:sym typeface="Roboto"/>
+              </a:rPr>
+              <a:t> Technologies </a:t>
+            </a:r>
+            <a:r>
+              <a:rPr lang="en-GB" sz="1200" dirty="0" err="1">
+                <a:solidFill>
+                  <a:srgbClr val="FFFFFF"/>
+                </a:solidFill>
+                <a:latin typeface="Roboto"/>
+                <a:ea typeface="Roboto"/>
+                <a:cs typeface="Roboto"/>
+                <a:sym typeface="Roboto"/>
+              </a:rPr>
+              <a:t>Pvt.</a:t>
+            </a:r>
+            <a:r>
+              <a:rPr lang="en-GB" sz="1200" dirty="0">
+                <a:solidFill>
+                  <a:srgbClr val="FFFFFF"/>
+                </a:solidFill>
+                <a:latin typeface="Roboto"/>
+                <a:ea typeface="Roboto"/>
+                <a:cs typeface="Roboto"/>
+                <a:sym typeface="Roboto"/>
+              </a:rPr>
+              <a:t> Ltd.</a:t>
+            </a:r>
+            <a:endParaRPr sz="1200" dirty="0">
+              <a:solidFill>
+                <a:srgbClr val="FFFFFF"/>
+              </a:solidFill>
+              <a:latin typeface="Roboto"/>
+              <a:ea typeface="Roboto"/>
+              <a:cs typeface="Roboto"/>
+              <a:sym typeface="Roboto"/>
+            </a:endParaRPr>
+          </a:p>
+        </p:txBody>
+      </p:sp>
+      <p:sp>
+        <p:nvSpPr>
+          <p:cNvPr id="354" name="Google Shape;354;p15">
+            <a:extLst>
+              <a:ext uri="{FF2B5EF4-FFF2-40B4-BE49-F238E27FC236}">
+                <a16:creationId xmlns:a16="http://schemas.microsoft.com/office/drawing/2014/main" id="{C92F108D-E52D-D003-0049-7F03EBD33A3D}"/>
+              </a:ext>
+            </a:extLst>
+          </p:cNvPr>
+          <p:cNvSpPr/>
+          <p:nvPr/>
+        </p:nvSpPr>
+        <p:spPr>
+          <a:xfrm rot="10800000">
+            <a:off x="11516800" y="130333"/>
+            <a:ext cx="675200" cy="755200"/>
+          </a:xfrm>
+          <a:prstGeom prst="rtTriangle">
+            <a:avLst/>
+          </a:prstGeom>
+          <a:solidFill>
+            <a:srgbClr val="FF9900"/>
+          </a:solidFill>
+          <a:ln>
+            <a:noFill/>
+          </a:ln>
+        </p:spPr>
+        <p:txBody>
+          <a:bodyPr spcFirstLastPara="1" wrap="square" lIns="121900" tIns="121900" rIns="121900" bIns="121900" anchor="ctr" anchorCtr="0">
+            <a:noAutofit/>
+          </a:bodyPr>
+          <a:lstStyle/>
+          <a:p>
+            <a:endParaRPr sz="2400"/>
+          </a:p>
+        </p:txBody>
+      </p:sp>
+      <p:sp>
+        <p:nvSpPr>
+          <p:cNvPr id="355" name="Google Shape;355;p15">
+            <a:extLst>
+              <a:ext uri="{FF2B5EF4-FFF2-40B4-BE49-F238E27FC236}">
+                <a16:creationId xmlns:a16="http://schemas.microsoft.com/office/drawing/2014/main" id="{7857BEFC-6843-2C6E-2D2E-3AF51D990ECC}"/>
+              </a:ext>
+            </a:extLst>
+          </p:cNvPr>
+          <p:cNvSpPr/>
+          <p:nvPr/>
+        </p:nvSpPr>
+        <p:spPr>
+          <a:xfrm>
+            <a:off x="0" y="6400800"/>
+            <a:ext cx="435200" cy="360800"/>
+          </a:xfrm>
+          <a:prstGeom prst="rtTriangle">
+            <a:avLst/>
+          </a:prstGeom>
+          <a:solidFill>
+            <a:srgbClr val="FF9900"/>
+          </a:solidFill>
+          <a:ln>
+            <a:noFill/>
+          </a:ln>
+        </p:spPr>
+        <p:txBody>
+          <a:bodyPr spcFirstLastPara="1" wrap="square" lIns="121900" tIns="121900" rIns="121900" bIns="121900" anchor="ctr" anchorCtr="0">
+            <a:noAutofit/>
+          </a:bodyPr>
+          <a:lstStyle/>
+          <a:p>
+            <a:endParaRPr sz="2400"/>
+          </a:p>
+        </p:txBody>
+      </p:sp>
+    </p:spTree>
+    <p:extLst>
+      <p:ext uri="{BB962C8B-B14F-4D97-AF65-F5344CB8AC3E}">
+        <p14:creationId xmlns:p14="http://schemas.microsoft.com/office/powerpoint/2010/main" val="3220203784"/>
+      </p:ext>
+    </p:extLst>
+  </p:cSld>
+  <p:clrMapOvr>
+    <a:masterClrMapping/>
+  </p:clrMapOvr>
+</p:sld>
+</file>
+
+<file path=ppt/slides/slide9.xml><?xml version="1.0" encoding="utf-8"?>
+<p:sld xmlns:a="http://schemas.openxmlformats.org/drawingml/2006/main" xmlns:r="http://schemas.openxmlformats.org/officeDocument/2006/relationships" xmlns:p="http://schemas.openxmlformats.org/presentationml/2006/main">
+  <p:cSld>
+    <p:spTree>
+      <p:nvGrpSpPr>
+        <p:cNvPr id="1" name=""/>
+        <p:cNvGrpSpPr/>
+        <p:nvPr/>
+      </p:nvGrpSpPr>
+      <p:grpSpPr>
+        <a:xfrm>
+          <a:off x="0" y="0"/>
+          <a:ext cx="0" cy="0"/>
+          <a:chOff x="0" y="0"/>
+          <a:chExt cx="0" cy="0"/>
+        </a:xfrm>
+      </p:grpSpPr>
+      <p:pic>
+        <p:nvPicPr>
+          <p:cNvPr id="3" name="Picture 2">
+            <a:extLst>
+              <a:ext uri="{FF2B5EF4-FFF2-40B4-BE49-F238E27FC236}">
+                <a16:creationId xmlns:a16="http://schemas.microsoft.com/office/drawing/2014/main" id="{73F6DCC4-591F-B9D2-3DD8-C03BA46462BA}"/>
+              </a:ext>
+            </a:extLst>
+          </p:cNvPr>
+          <p:cNvPicPr>
+            <a:picLocks noChangeAspect="1"/>
+          </p:cNvPicPr>
+          <p:nvPr/>
+        </p:nvPicPr>
+        <p:blipFill>
+          <a:blip r:embed="rId2"/>
+          <a:stretch>
+            <a:fillRect/>
+          </a:stretch>
+        </p:blipFill>
+        <p:spPr>
+          <a:xfrm>
+            <a:off x="0" y="0"/>
+            <a:ext cx="12192000" cy="6858000"/>
+          </a:xfrm>
+          <a:prstGeom prst="rect">
+            <a:avLst/>
+          </a:prstGeom>
+        </p:spPr>
+      </p:pic>
+    </p:spTree>
+    <p:extLst>
+      <p:ext uri="{BB962C8B-B14F-4D97-AF65-F5344CB8AC3E}">
+        <p14:creationId xmlns:p14="http://schemas.microsoft.com/office/powerpoint/2010/main" val="2113308478"/>
       </p:ext>
     </p:extLst>
   </p:cSld>

</xml_diff>